<commit_message>
feat(ppt): redesign sugon-ppt-template layouts (0.4.2)
Stronger hierarchy (≥0.65" margins, short red tick+rule, soft cards),
7-slide sample (cover/agenda/section/content/two-col/stats/closing).
</commit_message>
<xml_diff>
--- a/skills/sugon-ppt-template/examples/sample-deck.pptx
+++ b/skills/sugon-ppt-template/examples/sample-deck.pptx
@@ -10,9 +10,11 @@
     <p:sldId id="258" r:id="rId4"/>
     <p:sldId id="259" r:id="rId5"/>
     <p:sldId id="260" r:id="rId6"/>
+    <p:sldId id="261" r:id="rId7"/>
+    <p:sldId id="262" r:id="rId8"/>
   </p:sldIdLst>
   <p:notesMasterIdLst>
-    <p:notesMasterId r:id="rId7"/>
+    <p:notesMasterId r:id="rId9"/>
   </p:notesMasterIdLst>
   <p:sldSz cx="12191695" cy="6858000"/>
   <p:notesSz cx="6858000" cy="12191695"/>
@@ -900,6 +902,182 @@
 </p:notes>
 </file>
 
+<file path=ppt/notesSlides/notesSlide6.xml><?xml version="1.0" encoding="utf-8"?>
+<p:notes xmlns:a="http://schemas.openxmlformats.org/drawingml/2006/main" xmlns:r="http://schemas.openxmlformats.org/officeDocument/2006/relationships" xmlns:p="http://schemas.openxmlformats.org/presentationml/2006/main">
+  <p:cSld>
+    <p:spTree>
+      <p:nvGrpSpPr>
+        <p:cNvPr id="1" name=""/>
+        <p:cNvGrpSpPr/>
+        <p:nvPr/>
+      </p:nvGrpSpPr>
+      <p:grpSpPr>
+        <a:xfrm>
+          <a:off x="0" y="0"/>
+          <a:ext cx="0" cy="0"/>
+          <a:chOff x="0" y="0"/>
+          <a:chExt cx="0" cy="0"/>
+        </a:xfrm>
+      </p:grpSpPr>
+      <p:sp>
+        <p:nvSpPr>
+          <p:cNvPr id="2" name="Slide Image Placeholder 1"/>
+          <p:cNvSpPr>
+            <a:spLocks noGrp="1" noRot="1" noChangeAspect="1"/>
+          </p:cNvSpPr>
+          <p:nvPr>
+            <p:ph type="sldImg"/>
+          </p:nvPr>
+        </p:nvSpPr>
+        <p:spPr/>
+      </p:sp>
+      <p:sp>
+        <p:nvSpPr>
+          <p:cNvPr id="3" name="Notes Placeholder 2"/>
+          <p:cNvSpPr>
+            <a:spLocks noGrp="1"/>
+          </p:cNvSpPr>
+          <p:nvPr>
+            <p:ph type="body" idx="1"/>
+          </p:nvPr>
+        </p:nvSpPr>
+        <p:spPr/>
+        <p:txBody>
+          <a:bodyPr/>
+          <a:lstStyle/>
+          <a:p>
+            <a:r>
+              <a:rPr lang="en-US" dirty="0"/>
+              <a:t/>
+            </a:r>
+            <a:endParaRPr lang="en-US" dirty="0"/>
+          </a:p>
+        </p:txBody>
+      </p:sp>
+      <p:sp>
+        <p:nvSpPr>
+          <p:cNvPr id="4" name="Slide Number Placeholder 3"/>
+          <p:cNvSpPr>
+            <a:spLocks noGrp="1"/>
+          </p:cNvSpPr>
+          <p:nvPr>
+            <p:ph type="sldNum" sz="quarter" idx="10"/>
+          </p:nvPr>
+        </p:nvSpPr>
+        <p:spPr/>
+        <p:txBody>
+          <a:bodyPr/>
+          <a:lstStyle/>
+          <a:p>
+            <a:fld id="{F7021451-1387-4CA6-816F-3879F97B5CBC}" type="slidenum">
+              <a:rPr lang="en-US"/>
+              <a:t>6</a:t>
+            </a:fld>
+            <a:endParaRPr lang="en-US"/>
+          </a:p>
+        </p:txBody>
+      </p:sp>
+    </p:spTree>
+    <p:extLst>
+      <p:ext uri="{BB962C8B-B14F-4D97-AF65-F5344CB8AC3E}">
+        <p14:creationId xmlns:p14="http://schemas.microsoft.com/office/powerpoint/2010/main" val="1024086991"/>
+      </p:ext>
+    </p:extLst>
+  </p:cSld>
+  <p:clrMapOvr>
+    <a:masterClrMapping/>
+  </p:clrMapOvr>
+</p:notes>
+</file>
+
+<file path=ppt/notesSlides/notesSlide7.xml><?xml version="1.0" encoding="utf-8"?>
+<p:notes xmlns:a="http://schemas.openxmlformats.org/drawingml/2006/main" xmlns:r="http://schemas.openxmlformats.org/officeDocument/2006/relationships" xmlns:p="http://schemas.openxmlformats.org/presentationml/2006/main">
+  <p:cSld>
+    <p:spTree>
+      <p:nvGrpSpPr>
+        <p:cNvPr id="1" name=""/>
+        <p:cNvGrpSpPr/>
+        <p:nvPr/>
+      </p:nvGrpSpPr>
+      <p:grpSpPr>
+        <a:xfrm>
+          <a:off x="0" y="0"/>
+          <a:ext cx="0" cy="0"/>
+          <a:chOff x="0" y="0"/>
+          <a:chExt cx="0" cy="0"/>
+        </a:xfrm>
+      </p:grpSpPr>
+      <p:sp>
+        <p:nvSpPr>
+          <p:cNvPr id="2" name="Slide Image Placeholder 1"/>
+          <p:cNvSpPr>
+            <a:spLocks noGrp="1" noRot="1" noChangeAspect="1"/>
+          </p:cNvSpPr>
+          <p:nvPr>
+            <p:ph type="sldImg"/>
+          </p:nvPr>
+        </p:nvSpPr>
+        <p:spPr/>
+      </p:sp>
+      <p:sp>
+        <p:nvSpPr>
+          <p:cNvPr id="3" name="Notes Placeholder 2"/>
+          <p:cNvSpPr>
+            <a:spLocks noGrp="1"/>
+          </p:cNvSpPr>
+          <p:nvPr>
+            <p:ph type="body" idx="1"/>
+          </p:nvPr>
+        </p:nvSpPr>
+        <p:spPr/>
+        <p:txBody>
+          <a:bodyPr/>
+          <a:lstStyle/>
+          <a:p>
+            <a:r>
+              <a:rPr lang="en-US" dirty="0"/>
+              <a:t/>
+            </a:r>
+            <a:endParaRPr lang="en-US" dirty="0"/>
+          </a:p>
+        </p:txBody>
+      </p:sp>
+      <p:sp>
+        <p:nvSpPr>
+          <p:cNvPr id="4" name="Slide Number Placeholder 3"/>
+          <p:cNvSpPr>
+            <a:spLocks noGrp="1"/>
+          </p:cNvSpPr>
+          <p:nvPr>
+            <p:ph type="sldNum" sz="quarter" idx="10"/>
+          </p:nvPr>
+        </p:nvSpPr>
+        <p:spPr/>
+        <p:txBody>
+          <a:bodyPr/>
+          <a:lstStyle/>
+          <a:p>
+            <a:fld id="{F7021451-1387-4CA6-816F-3879F97B5CBC}" type="slidenum">
+              <a:rPr lang="en-US"/>
+              <a:t>7</a:t>
+            </a:fld>
+            <a:endParaRPr lang="en-US"/>
+          </a:p>
+        </p:txBody>
+      </p:sp>
+    </p:spTree>
+    <p:extLst>
+      <p:ext uri="{BB962C8B-B14F-4D97-AF65-F5344CB8AC3E}">
+        <p14:creationId xmlns:p14="http://schemas.microsoft.com/office/powerpoint/2010/main" val="1024086991"/>
+      </p:ext>
+    </p:extLst>
+  </p:cSld>
+  <p:clrMapOvr>
+    <a:masterClrMapping/>
+  </p:clrMapOvr>
+</p:notes>
+</file>
+
 <file path=ppt/slideLayouts/slideLayout1.xml><?xml version="1.0" encoding="utf-8"?>
 <p:sldLayout xmlns:a="http://schemas.openxmlformats.org/drawingml/2006/main" xmlns:r="http://schemas.openxmlformats.org/officeDocument/2006/relationships" xmlns:p="http://schemas.openxmlformats.org/presentationml/2006/main" preserve="1">
   <p:cSld name="DEFAULT">
@@ -1244,29 +1422,9 @@
           <a:ln/>
         </p:spPr>
       </p:sp>
-      <p:sp>
-        <p:nvSpPr>
-          <p:cNvPr id="3" name="Shape 1"/>
-          <p:cNvSpPr/>
-          <p:nvPr/>
-        </p:nvSpPr>
-        <p:spPr>
-          <a:xfrm>
-            <a:off x="0" y="6537960"/>
-            <a:ext cx="12191695" cy="320040"/>
-          </a:xfrm>
-          <a:prstGeom prst="rect">
-            <a:avLst/>
-          </a:prstGeom>
-          <a:solidFill>
-            <a:srgbClr val="AF1F24"/>
-          </a:solidFill>
-          <a:ln/>
-        </p:spPr>
-      </p:sp>
       <p:pic>
         <p:nvPicPr>
-          <p:cNvPr id="4" name="Image 0" descr="/workspace/test02-work/repo/skills/sugon-ppt-template/assets/logo.png">    </p:cNvPr>
+          <p:cNvPr id="3" name="Image 0" descr="/workspace/test02-work/repo/skills/sugon-ppt-template/assets/logo.png">    </p:cNvPr>
           <p:cNvPicPr>
             <a:picLocks noChangeAspect="1"/>
           </p:cNvPicPr>
@@ -1280,8 +1438,8 @@
         </p:blipFill>
         <p:spPr>
           <a:xfrm>
-            <a:off x="502920" y="411480"/>
-            <a:ext cx="1828800" cy="729769"/>
+            <a:off x="594360" y="411480"/>
+            <a:ext cx="1874520" cy="748013"/>
           </a:xfrm>
           <a:prstGeom prst="rect">
             <a:avLst/>
@@ -1290,14 +1448,14 @@
       </p:pic>
       <p:sp>
         <p:nvSpPr>
-          <p:cNvPr id="5" name="Text 2"/>
-          <p:cNvSpPr/>
-          <p:nvPr/>
-        </p:nvSpPr>
-        <p:spPr>
-          <a:xfrm>
-            <a:off x="502920" y="2194560"/>
-            <a:ext cx="11155680" cy="1005840"/>
+          <p:cNvPr id="4" name="Text 1"/>
+          <p:cNvSpPr/>
+          <p:nvPr/>
+        </p:nvSpPr>
+        <p:spPr>
+          <a:xfrm>
+            <a:off x="594360" y="2148840"/>
+            <a:ext cx="11002975" cy="1051560"/>
           </a:xfrm>
           <a:prstGeom prst="rect">
             <a:avLst/>
@@ -1313,7 +1471,7 @@
               <a:buNone/>
             </a:pPr>
             <a:r>
-              <a:rPr lang="en-US" sz="3600" b="1" dirty="0">
+              <a:rPr lang="en-US" sz="4000" b="1" dirty="0">
                 <a:solidFill>
                   <a:srgbClr val="171717"/>
                 </a:solidFill>
@@ -1321,11 +1479,31 @@
                 <a:ea typeface="Source Han Sans SC" pitchFamily="34" charset="-122"/>
                 <a:cs typeface="Source Han Sans SC" pitchFamily="34" charset="-120"/>
               </a:rPr>
-              <a:t>曙光云产品能力汇报</a:t>
-            </a:r>
-            <a:endParaRPr lang="en-US" sz="3600" dirty="0"/>
-          </a:p>
-        </p:txBody>
+              <a:t>曙光云算力与运维能力汇报</a:t>
+            </a:r>
+            <a:endParaRPr lang="en-US" sz="4000" dirty="0"/>
+          </a:p>
+        </p:txBody>
+      </p:sp>
+      <p:sp>
+        <p:nvSpPr>
+          <p:cNvPr id="5" name="Shape 2"/>
+          <p:cNvSpPr/>
+          <p:nvPr/>
+        </p:nvSpPr>
+        <p:spPr>
+          <a:xfrm>
+            <a:off x="594360" y="3337560"/>
+            <a:ext cx="2560320" cy="41148"/>
+          </a:xfrm>
+          <a:prstGeom prst="rect">
+            <a:avLst/>
+          </a:prstGeom>
+          <a:solidFill>
+            <a:srgbClr val="AF1F24"/>
+          </a:solidFill>
+          <a:ln/>
+        </p:spPr>
       </p:sp>
       <p:sp>
         <p:nvSpPr>
@@ -1335,8 +1513,8 @@
         </p:nvSpPr>
         <p:spPr>
           <a:xfrm>
-            <a:off x="502920" y="3291840"/>
-            <a:ext cx="11155680" cy="411480"/>
+            <a:off x="594360" y="3566160"/>
+            <a:ext cx="9352529" cy="457200"/>
           </a:xfrm>
           <a:prstGeom prst="rect">
             <a:avLst/>
@@ -1360,7 +1538,7 @@
                 <a:ea typeface="Source Han Sans SC" pitchFamily="34" charset="-122"/>
                 <a:cs typeface="Source Han Sans SC" pitchFamily="34" charset="-120"/>
               </a:rPr>
-              <a:t>通用 16:9 模板样例（无官方母版时的草稿）</a:t>
+              <a:t>面向政企客户的交付进展与下一步计划</a:t>
             </a:r>
             <a:endParaRPr lang="en-US" sz="1800" dirty="0"/>
           </a:p>
@@ -1374,8 +1552,8 @@
         </p:nvSpPr>
         <p:spPr>
           <a:xfrm>
-            <a:off x="502920" y="5029200"/>
-            <a:ext cx="11155680" cy="365760"/>
+            <a:off x="594360" y="5989320"/>
+            <a:ext cx="11002975" cy="320040"/>
           </a:xfrm>
           <a:prstGeom prst="rect">
             <a:avLst/>
@@ -1399,7 +1577,7 @@
                 <a:ea typeface="Source Han Sans SC" pitchFamily="34" charset="-122"/>
                 <a:cs typeface="Source Han Sans SC" pitchFamily="34" charset="-120"/>
               </a:rPr>
-              <a:t>曙光云  ·  2026 年 10 月</a:t>
+              <a:t>曙光云    2026 年 10 月</a:t>
             </a:r>
             <a:endParaRPr lang="en-US" sz="1400" dirty="0"/>
           </a:p>
@@ -1430,29 +1608,9 @@
           <a:chExt cx="0" cy="0"/>
         </a:xfrm>
       </p:grpSpPr>
-      <p:sp>
-        <p:nvSpPr>
-          <p:cNvPr id="2" name="Shape 0"/>
-          <p:cNvSpPr/>
-          <p:nvPr/>
-        </p:nvSpPr>
-        <p:spPr>
-          <a:xfrm>
-            <a:off x="0" y="0"/>
-            <a:ext cx="109728" cy="6858000"/>
-          </a:xfrm>
-          <a:prstGeom prst="rect">
-            <a:avLst/>
-          </a:prstGeom>
-          <a:solidFill>
-            <a:srgbClr val="AF1F24"/>
-          </a:solidFill>
-          <a:ln/>
-        </p:spPr>
-      </p:sp>
       <p:pic>
         <p:nvPicPr>
-          <p:cNvPr id="3" name="Image 0" descr="/workspace/test02-work/repo/skills/sugon-ppt-template/assets/logo.png">    </p:cNvPr>
+          <p:cNvPr id="2" name="Image 0" descr="/workspace/test02-work/repo/skills/sugon-ppt-template/assets/logo.png">    </p:cNvPr>
           <p:cNvPicPr>
             <a:picLocks noChangeAspect="1"/>
           </p:cNvPicPr>
@@ -1466,8 +1624,8 @@
         </p:blipFill>
         <p:spPr>
           <a:xfrm>
-            <a:off x="10241280" y="320040"/>
-            <a:ext cx="1463040" cy="583815"/>
+            <a:off x="10180015" y="347472"/>
+            <a:ext cx="1417320" cy="565571"/>
           </a:xfrm>
           <a:prstGeom prst="rect">
             <a:avLst/>
@@ -1476,14 +1634,34 @@
       </p:pic>
       <p:sp>
         <p:nvSpPr>
+          <p:cNvPr id="3" name="Shape 0"/>
+          <p:cNvSpPr/>
+          <p:nvPr/>
+        </p:nvSpPr>
+        <p:spPr>
+          <a:xfrm>
+            <a:off x="594360" y="438912"/>
+            <a:ext cx="73152" cy="384048"/>
+          </a:xfrm>
+          <a:prstGeom prst="rect">
+            <a:avLst/>
+          </a:prstGeom>
+          <a:solidFill>
+            <a:srgbClr val="AF1F24"/>
+          </a:solidFill>
+          <a:ln/>
+        </p:spPr>
+      </p:sp>
+      <p:sp>
+        <p:nvSpPr>
           <p:cNvPr id="4" name="Text 1"/>
           <p:cNvSpPr/>
           <p:nvPr/>
         </p:nvSpPr>
         <p:spPr>
           <a:xfrm>
-            <a:off x="502920" y="411480"/>
-            <a:ext cx="9144000" cy="502920"/>
+            <a:off x="795528" y="347472"/>
+            <a:ext cx="9174175" cy="640080"/>
           </a:xfrm>
           <a:prstGeom prst="rect">
             <a:avLst/>
@@ -1499,7 +1677,7 @@
               <a:buNone/>
             </a:pPr>
             <a:r>
-              <a:rPr lang="en-US" sz="2800" b="1" dirty="0">
+              <a:rPr lang="en-US" sz="2600" b="1" dirty="0">
                 <a:solidFill>
                   <a:srgbClr val="171717"/>
                 </a:solidFill>
@@ -1509,111 +1687,29 @@
               </a:rPr>
               <a:t>目录</a:t>
             </a:r>
-            <a:endParaRPr lang="en-US" sz="2800" dirty="0"/>
-          </a:p>
-        </p:txBody>
-      </p:sp>
-      <p:sp>
-        <p:nvSpPr>
-          <p:cNvPr id="5" name="Text 2"/>
-          <p:cNvSpPr/>
-          <p:nvPr/>
-        </p:nvSpPr>
-        <p:spPr>
-          <a:xfrm>
-            <a:off x="640080" y="1371600"/>
-            <a:ext cx="10515600" cy="4114800"/>
-          </a:xfrm>
-          <a:prstGeom prst="rect">
-            <a:avLst/>
-          </a:prstGeom>
-          <a:noFill/>
-          <a:ln/>
-        </p:spPr>
-        <p:txBody>
-          <a:bodyPr wrap="square" lIns="0" tIns="0" rIns="0" bIns="0" rtlCol="0" anchor="ctr"/>
-          <a:lstStyle/>
-          <a:p>
-            <a:pPr indent="0" marL="0">
-              <a:spcAft>
-                <a:spcPts val="1000"/>
-              </a:spcAft>
-              <a:buNone/>
-            </a:pPr>
-            <a:r>
-              <a:rPr lang="en-US" sz="2000" dirty="0">
-                <a:solidFill>
-                  <a:srgbClr val="171717"/>
-                </a:solidFill>
-                <a:latin typeface="Source Han Sans SC" pitchFamily="34" charset="0"/>
-                <a:ea typeface="Source Han Sans SC" pitchFamily="34" charset="-122"/>
-                <a:cs typeface="Source Han Sans SC" pitchFamily="34" charset="-120"/>
-              </a:rPr>
-              <a:t>1.  背景与目标</a:t>
-            </a:r>
-            <a:endParaRPr lang="en-US" sz="2000" dirty="0"/>
-          </a:p>
-          <a:p>
-            <a:pPr indent="0" marL="0">
-              <a:spcAft>
-                <a:spcPts val="1000"/>
-              </a:spcAft>
-              <a:buNone/>
-            </a:pPr>
-            <a:r>
-              <a:rPr lang="en-US" sz="2000" dirty="0">
-                <a:solidFill>
-                  <a:srgbClr val="171717"/>
-                </a:solidFill>
-                <a:latin typeface="Source Han Sans SC" pitchFamily="34" charset="0"/>
-                <a:ea typeface="Source Han Sans SC" pitchFamily="34" charset="-122"/>
-                <a:cs typeface="Source Han Sans SC" pitchFamily="34" charset="-120"/>
-              </a:rPr>
-              <a:t>2.  核心能力</a:t>
-            </a:r>
-            <a:endParaRPr lang="en-US" sz="2000" dirty="0"/>
-          </a:p>
-          <a:p>
-            <a:pPr indent="0" marL="0">
-              <a:spcAft>
-                <a:spcPts val="1000"/>
-              </a:spcAft>
-              <a:buNone/>
-            </a:pPr>
-            <a:r>
-              <a:rPr lang="en-US" sz="2000" dirty="0">
-                <a:solidFill>
-                  <a:srgbClr val="171717"/>
-                </a:solidFill>
-                <a:latin typeface="Source Han Sans SC" pitchFamily="34" charset="0"/>
-                <a:ea typeface="Source Han Sans SC" pitchFamily="34" charset="-122"/>
-                <a:cs typeface="Source Han Sans SC" pitchFamily="34" charset="-120"/>
-              </a:rPr>
-              <a:t>3.  落地进展</a:t>
-            </a:r>
-            <a:endParaRPr lang="en-US" sz="2000" dirty="0"/>
-          </a:p>
-          <a:p>
-            <a:pPr indent="0" marL="0">
-              <a:spcAft>
-                <a:spcPts val="1000"/>
-              </a:spcAft>
-              <a:buNone/>
-            </a:pPr>
-            <a:r>
-              <a:rPr lang="en-US" sz="2000" dirty="0">
-                <a:solidFill>
-                  <a:srgbClr val="171717"/>
-                </a:solidFill>
-                <a:latin typeface="Source Han Sans SC" pitchFamily="34" charset="0"/>
-                <a:ea typeface="Source Han Sans SC" pitchFamily="34" charset="-122"/>
-                <a:cs typeface="Source Han Sans SC" pitchFamily="34" charset="-120"/>
-              </a:rPr>
-              <a:t>4.  下一步计划</a:t>
-            </a:r>
-            <a:endParaRPr lang="en-US" sz="2000" dirty="0"/>
-          </a:p>
-        </p:txBody>
+            <a:endParaRPr lang="en-US" sz="2600" dirty="0"/>
+          </a:p>
+        </p:txBody>
+      </p:sp>
+      <p:sp>
+        <p:nvSpPr>
+          <p:cNvPr id="5" name="Shape 2"/>
+          <p:cNvSpPr/>
+          <p:nvPr/>
+        </p:nvSpPr>
+        <p:spPr>
+          <a:xfrm>
+            <a:off x="594360" y="1051560"/>
+            <a:ext cx="2194560" cy="32004"/>
+          </a:xfrm>
+          <a:prstGeom prst="rect">
+            <a:avLst/>
+          </a:prstGeom>
+          <a:solidFill>
+            <a:srgbClr val="AF1F24"/>
+          </a:solidFill>
+          <a:ln/>
+        </p:spPr>
       </p:sp>
       <p:sp>
         <p:nvSpPr>
@@ -1623,8 +1719,8 @@
         </p:nvSpPr>
         <p:spPr>
           <a:xfrm>
-            <a:off x="457200" y="6492240"/>
-            <a:ext cx="7315200" cy="228600"/>
+            <a:off x="594360" y="1417320"/>
+            <a:ext cx="777240" cy="502920"/>
           </a:xfrm>
           <a:prstGeom prst="rect">
             <a:avLst/>
@@ -1640,6 +1736,378 @@
               <a:buNone/>
             </a:pPr>
             <a:r>
+              <a:rPr lang="en-US" sz="2800" b="1" dirty="0">
+                <a:solidFill>
+                  <a:srgbClr val="AF1F24"/>
+                </a:solidFill>
+                <a:latin typeface="Source Han Sans SC" pitchFamily="34" charset="0"/>
+                <a:ea typeface="Source Han Sans SC" pitchFamily="34" charset="-122"/>
+                <a:cs typeface="Source Han Sans SC" pitchFamily="34" charset="-120"/>
+              </a:rPr>
+              <a:t>01</a:t>
+            </a:r>
+            <a:endParaRPr lang="en-US" sz="2800" dirty="0"/>
+          </a:p>
+        </p:txBody>
+      </p:sp>
+      <p:sp>
+        <p:nvSpPr>
+          <p:cNvPr id="7" name="Text 4"/>
+          <p:cNvSpPr/>
+          <p:nvPr/>
+        </p:nvSpPr>
+        <p:spPr>
+          <a:xfrm>
+            <a:off x="1554480" y="1417320"/>
+            <a:ext cx="9905695" cy="502920"/>
+          </a:xfrm>
+          <a:prstGeom prst="rect">
+            <a:avLst/>
+          </a:prstGeom>
+          <a:noFill/>
+          <a:ln/>
+        </p:spPr>
+        <p:txBody>
+          <a:bodyPr wrap="square" lIns="0" tIns="0" rIns="0" bIns="0" rtlCol="0" anchor="ctr"/>
+          <a:lstStyle/>
+          <a:p>
+            <a:pPr indent="0" marL="0">
+              <a:buNone/>
+            </a:pPr>
+            <a:r>
+              <a:rPr lang="en-US" sz="1800" dirty="0">
+                <a:solidFill>
+                  <a:srgbClr val="171717"/>
+                </a:solidFill>
+                <a:latin typeface="Source Han Sans SC" pitchFamily="34" charset="0"/>
+                <a:ea typeface="Source Han Sans SC" pitchFamily="34" charset="-122"/>
+                <a:cs typeface="Source Han Sans SC" pitchFamily="34" charset="-120"/>
+              </a:rPr>
+              <a:t>背景与目标已经对齐重点客户诉求</a:t>
+            </a:r>
+            <a:endParaRPr lang="en-US" sz="1800" dirty="0"/>
+          </a:p>
+        </p:txBody>
+      </p:sp>
+      <p:sp>
+        <p:nvSpPr>
+          <p:cNvPr id="8" name="Shape 5"/>
+          <p:cNvSpPr/>
+          <p:nvPr/>
+        </p:nvSpPr>
+        <p:spPr>
+          <a:xfrm>
+            <a:off x="1554480" y="2075688"/>
+            <a:ext cx="9905695" cy="9144"/>
+          </a:xfrm>
+          <a:prstGeom prst="rect">
+            <a:avLst/>
+          </a:prstGeom>
+          <a:solidFill>
+            <a:srgbClr val="E5E5E5"/>
+          </a:solidFill>
+          <a:ln/>
+        </p:spPr>
+      </p:sp>
+      <p:sp>
+        <p:nvSpPr>
+          <p:cNvPr id="9" name="Text 6"/>
+          <p:cNvSpPr/>
+          <p:nvPr/>
+        </p:nvSpPr>
+        <p:spPr>
+          <a:xfrm>
+            <a:off x="594360" y="2377440"/>
+            <a:ext cx="777240" cy="502920"/>
+          </a:xfrm>
+          <a:prstGeom prst="rect">
+            <a:avLst/>
+          </a:prstGeom>
+          <a:noFill/>
+          <a:ln/>
+        </p:spPr>
+        <p:txBody>
+          <a:bodyPr wrap="square" lIns="0" tIns="0" rIns="0" bIns="0" rtlCol="0" anchor="ctr"/>
+          <a:lstStyle/>
+          <a:p>
+            <a:pPr indent="0" marL="0">
+              <a:buNone/>
+            </a:pPr>
+            <a:r>
+              <a:rPr lang="en-US" sz="2800" b="1" dirty="0">
+                <a:solidFill>
+                  <a:srgbClr val="AF1F24"/>
+                </a:solidFill>
+                <a:latin typeface="Source Han Sans SC" pitchFamily="34" charset="0"/>
+                <a:ea typeface="Source Han Sans SC" pitchFamily="34" charset="-122"/>
+                <a:cs typeface="Source Han Sans SC" pitchFamily="34" charset="-120"/>
+              </a:rPr>
+              <a:t>02</a:t>
+            </a:r>
+            <a:endParaRPr lang="en-US" sz="2800" dirty="0"/>
+          </a:p>
+        </p:txBody>
+      </p:sp>
+      <p:sp>
+        <p:nvSpPr>
+          <p:cNvPr id="10" name="Text 7"/>
+          <p:cNvSpPr/>
+          <p:nvPr/>
+        </p:nvSpPr>
+        <p:spPr>
+          <a:xfrm>
+            <a:off x="1554480" y="2377440"/>
+            <a:ext cx="9905695" cy="502920"/>
+          </a:xfrm>
+          <a:prstGeom prst="rect">
+            <a:avLst/>
+          </a:prstGeom>
+          <a:noFill/>
+          <a:ln/>
+        </p:spPr>
+        <p:txBody>
+          <a:bodyPr wrap="square" lIns="0" tIns="0" rIns="0" bIns="0" rtlCol="0" anchor="ctr"/>
+          <a:lstStyle/>
+          <a:p>
+            <a:pPr indent="0" marL="0">
+              <a:buNone/>
+            </a:pPr>
+            <a:r>
+              <a:rPr lang="en-US" sz="1800" dirty="0">
+                <a:solidFill>
+                  <a:srgbClr val="171717"/>
+                </a:solidFill>
+                <a:latin typeface="Source Han Sans SC" pitchFamily="34" charset="0"/>
+                <a:ea typeface="Source Han Sans SC" pitchFamily="34" charset="-122"/>
+                <a:cs typeface="Source Han Sans SC" pitchFamily="34" charset="-120"/>
+              </a:rPr>
+              <a:t>核心能力覆盖调度、监控与集成</a:t>
+            </a:r>
+            <a:endParaRPr lang="en-US" sz="1800" dirty="0"/>
+          </a:p>
+        </p:txBody>
+      </p:sp>
+      <p:sp>
+        <p:nvSpPr>
+          <p:cNvPr id="11" name="Shape 8"/>
+          <p:cNvSpPr/>
+          <p:nvPr/>
+        </p:nvSpPr>
+        <p:spPr>
+          <a:xfrm>
+            <a:off x="1554480" y="3035808"/>
+            <a:ext cx="9905695" cy="9144"/>
+          </a:xfrm>
+          <a:prstGeom prst="rect">
+            <a:avLst/>
+          </a:prstGeom>
+          <a:solidFill>
+            <a:srgbClr val="E5E5E5"/>
+          </a:solidFill>
+          <a:ln/>
+        </p:spPr>
+      </p:sp>
+      <p:sp>
+        <p:nvSpPr>
+          <p:cNvPr id="12" name="Text 9"/>
+          <p:cNvSpPr/>
+          <p:nvPr/>
+        </p:nvSpPr>
+        <p:spPr>
+          <a:xfrm>
+            <a:off x="594360" y="3337560"/>
+            <a:ext cx="777240" cy="502920"/>
+          </a:xfrm>
+          <a:prstGeom prst="rect">
+            <a:avLst/>
+          </a:prstGeom>
+          <a:noFill/>
+          <a:ln/>
+        </p:spPr>
+        <p:txBody>
+          <a:bodyPr wrap="square" lIns="0" tIns="0" rIns="0" bIns="0" rtlCol="0" anchor="ctr"/>
+          <a:lstStyle/>
+          <a:p>
+            <a:pPr indent="0" marL="0">
+              <a:buNone/>
+            </a:pPr>
+            <a:r>
+              <a:rPr lang="en-US" sz="2800" b="1" dirty="0">
+                <a:solidFill>
+                  <a:srgbClr val="AF1F24"/>
+                </a:solidFill>
+                <a:latin typeface="Source Han Sans SC" pitchFamily="34" charset="0"/>
+                <a:ea typeface="Source Han Sans SC" pitchFamily="34" charset="-122"/>
+                <a:cs typeface="Source Han Sans SC" pitchFamily="34" charset="-120"/>
+              </a:rPr>
+              <a:t>03</a:t>
+            </a:r>
+            <a:endParaRPr lang="en-US" sz="2800" dirty="0"/>
+          </a:p>
+        </p:txBody>
+      </p:sp>
+      <p:sp>
+        <p:nvSpPr>
+          <p:cNvPr id="13" name="Text 10"/>
+          <p:cNvSpPr/>
+          <p:nvPr/>
+        </p:nvSpPr>
+        <p:spPr>
+          <a:xfrm>
+            <a:off x="1554480" y="3337560"/>
+            <a:ext cx="9905695" cy="502920"/>
+          </a:xfrm>
+          <a:prstGeom prst="rect">
+            <a:avLst/>
+          </a:prstGeom>
+          <a:noFill/>
+          <a:ln/>
+        </p:spPr>
+        <p:txBody>
+          <a:bodyPr wrap="square" lIns="0" tIns="0" rIns="0" bIns="0" rtlCol="0" anchor="ctr"/>
+          <a:lstStyle/>
+          <a:p>
+            <a:pPr indent="0" marL="0">
+              <a:buNone/>
+            </a:pPr>
+            <a:r>
+              <a:rPr lang="en-US" sz="1800" dirty="0">
+                <a:solidFill>
+                  <a:srgbClr val="171717"/>
+                </a:solidFill>
+                <a:latin typeface="Source Han Sans SC" pitchFamily="34" charset="0"/>
+                <a:ea typeface="Source Han Sans SC" pitchFamily="34" charset="-122"/>
+                <a:cs typeface="Source Han Sans SC" pitchFamily="34" charset="-120"/>
+              </a:rPr>
+              <a:t>本季度三项落地按期完成</a:t>
+            </a:r>
+            <a:endParaRPr lang="en-US" sz="1800" dirty="0"/>
+          </a:p>
+        </p:txBody>
+      </p:sp>
+      <p:sp>
+        <p:nvSpPr>
+          <p:cNvPr id="14" name="Shape 11"/>
+          <p:cNvSpPr/>
+          <p:nvPr/>
+        </p:nvSpPr>
+        <p:spPr>
+          <a:xfrm>
+            <a:off x="1554480" y="3995928"/>
+            <a:ext cx="9905695" cy="9144"/>
+          </a:xfrm>
+          <a:prstGeom prst="rect">
+            <a:avLst/>
+          </a:prstGeom>
+          <a:solidFill>
+            <a:srgbClr val="E5E5E5"/>
+          </a:solidFill>
+          <a:ln/>
+        </p:spPr>
+      </p:sp>
+      <p:sp>
+        <p:nvSpPr>
+          <p:cNvPr id="15" name="Text 12"/>
+          <p:cNvSpPr/>
+          <p:nvPr/>
+        </p:nvSpPr>
+        <p:spPr>
+          <a:xfrm>
+            <a:off x="594360" y="4297680"/>
+            <a:ext cx="777240" cy="502920"/>
+          </a:xfrm>
+          <a:prstGeom prst="rect">
+            <a:avLst/>
+          </a:prstGeom>
+          <a:noFill/>
+          <a:ln/>
+        </p:spPr>
+        <p:txBody>
+          <a:bodyPr wrap="square" lIns="0" tIns="0" rIns="0" bIns="0" rtlCol="0" anchor="ctr"/>
+          <a:lstStyle/>
+          <a:p>
+            <a:pPr indent="0" marL="0">
+              <a:buNone/>
+            </a:pPr>
+            <a:r>
+              <a:rPr lang="en-US" sz="2800" b="1" dirty="0">
+                <a:solidFill>
+                  <a:srgbClr val="AF1F24"/>
+                </a:solidFill>
+                <a:latin typeface="Source Han Sans SC" pitchFamily="34" charset="0"/>
+                <a:ea typeface="Source Han Sans SC" pitchFamily="34" charset="-122"/>
+                <a:cs typeface="Source Han Sans SC" pitchFamily="34" charset="-120"/>
+              </a:rPr>
+              <a:t>04</a:t>
+            </a:r>
+            <a:endParaRPr lang="en-US" sz="2800" dirty="0"/>
+          </a:p>
+        </p:txBody>
+      </p:sp>
+      <p:sp>
+        <p:nvSpPr>
+          <p:cNvPr id="16" name="Text 13"/>
+          <p:cNvSpPr/>
+          <p:nvPr/>
+        </p:nvSpPr>
+        <p:spPr>
+          <a:xfrm>
+            <a:off x="1554480" y="4297680"/>
+            <a:ext cx="9905695" cy="502920"/>
+          </a:xfrm>
+          <a:prstGeom prst="rect">
+            <a:avLst/>
+          </a:prstGeom>
+          <a:noFill/>
+          <a:ln/>
+        </p:spPr>
+        <p:txBody>
+          <a:bodyPr wrap="square" lIns="0" tIns="0" rIns="0" bIns="0" rtlCol="0" anchor="ctr"/>
+          <a:lstStyle/>
+          <a:p>
+            <a:pPr indent="0" marL="0">
+              <a:buNone/>
+            </a:pPr>
+            <a:r>
+              <a:rPr lang="en-US" sz="1800" dirty="0">
+                <a:solidFill>
+                  <a:srgbClr val="171717"/>
+                </a:solidFill>
+                <a:latin typeface="Source Han Sans SC" pitchFamily="34" charset="0"/>
+                <a:ea typeface="Source Han Sans SC" pitchFamily="34" charset="-122"/>
+                <a:cs typeface="Source Han Sans SC" pitchFamily="34" charset="-120"/>
+              </a:rPr>
+              <a:t>下一步聚焦规模化与规范沉淀</a:t>
+            </a:r>
+            <a:endParaRPr lang="en-US" sz="1800" dirty="0"/>
+          </a:p>
+        </p:txBody>
+      </p:sp>
+      <p:sp>
+        <p:nvSpPr>
+          <p:cNvPr id="17" name="Text 14"/>
+          <p:cNvSpPr/>
+          <p:nvPr/>
+        </p:nvSpPr>
+        <p:spPr>
+          <a:xfrm>
+            <a:off x="594360" y="6510528"/>
+            <a:ext cx="6400800" cy="201168"/>
+          </a:xfrm>
+          <a:prstGeom prst="rect">
+            <a:avLst/>
+          </a:prstGeom>
+          <a:noFill/>
+          <a:ln/>
+        </p:spPr>
+        <p:txBody>
+          <a:bodyPr wrap="square" lIns="0" tIns="0" rIns="0" bIns="0" rtlCol="0" anchor="ctr"/>
+          <a:lstStyle/>
+          <a:p>
+            <a:pPr indent="0" marL="0">
+              <a:buNone/>
+            </a:pPr>
+            <a:r>
               <a:rPr lang="en-US" sz="1000" dirty="0">
                 <a:solidFill>
                   <a:srgbClr val="525252"/>
@@ -1656,14 +2124,14 @@
       </p:sp>
       <p:sp>
         <p:nvSpPr>
-          <p:cNvPr id="7" name="Text 4"/>
-          <p:cNvSpPr/>
-          <p:nvPr/>
-        </p:nvSpPr>
-        <p:spPr>
-          <a:xfrm>
-            <a:off x="10515600" y="6492240"/>
-            <a:ext cx="1188720" cy="228600"/>
+          <p:cNvPr id="18" name="Text 15"/>
+          <p:cNvSpPr/>
+          <p:nvPr/>
+        </p:nvSpPr>
+        <p:spPr>
+          <a:xfrm>
+            <a:off x="10500055" y="6510528"/>
+            <a:ext cx="1097280" cy="201168"/>
           </a:xfrm>
           <a:prstGeom prst="rect">
             <a:avLst/>
@@ -1687,7 +2155,7 @@
                 <a:ea typeface="Source Han Sans SC" pitchFamily="34" charset="-122"/>
                 <a:cs typeface="Source Han Sans SC" pitchFamily="34" charset="-120"/>
               </a:rPr>
-              <a:t>2 / 5</a:t>
+              <a:t>2 / 7</a:t>
             </a:r>
             <a:endParaRPr lang="en-US" sz="1000" dirty="0"/>
           </a:p>
@@ -1727,13 +2195,13 @@
         <p:spPr>
           <a:xfrm>
             <a:off x="0" y="0"/>
-            <a:ext cx="109728" cy="6858000"/>
-          </a:xfrm>
-          <a:prstGeom prst="rect">
-            <a:avLst/>
-          </a:prstGeom>
-          <a:solidFill>
-            <a:srgbClr val="AF1F24"/>
+            <a:ext cx="12191695" cy="6858000"/>
+          </a:xfrm>
+          <a:prstGeom prst="rect">
+            <a:avLst/>
+          </a:prstGeom>
+          <a:solidFill>
+            <a:srgbClr val="FAFAFA"/>
           </a:solidFill>
           <a:ln/>
         </p:spPr>
@@ -1754,8 +2222,8 @@
         </p:blipFill>
         <p:spPr>
           <a:xfrm>
-            <a:off x="10241280" y="320040"/>
-            <a:ext cx="1463040" cy="583815"/>
+            <a:off x="10180015" y="347472"/>
+            <a:ext cx="1417320" cy="565571"/>
           </a:xfrm>
           <a:prstGeom prst="rect">
             <a:avLst/>
@@ -1770,8 +2238,8 @@
         </p:nvSpPr>
         <p:spPr>
           <a:xfrm>
-            <a:off x="502920" y="365760"/>
-            <a:ext cx="9418320" cy="822960"/>
+            <a:off x="594360" y="2194560"/>
+            <a:ext cx="11002975" cy="640080"/>
           </a:xfrm>
           <a:prstGeom prst="rect">
             <a:avLst/>
@@ -1787,17 +2255,17 @@
               <a:buNone/>
             </a:pPr>
             <a:r>
-              <a:rPr lang="en-US" sz="2400" b="1" dirty="0">
-                <a:solidFill>
-                  <a:srgbClr val="171717"/>
-                </a:solidFill>
-                <a:latin typeface="Source Han Sans SC" pitchFamily="34" charset="0"/>
-                <a:ea typeface="Source Han Sans SC" pitchFamily="34" charset="-122"/>
-                <a:cs typeface="Source Han Sans SC" pitchFamily="34" charset="-120"/>
-              </a:rPr>
-              <a:t>核心能力已覆盖算力调度与运维闭环</a:t>
-            </a:r>
-            <a:endParaRPr lang="en-US" sz="2400" dirty="0"/>
+              <a:rPr lang="en-US" sz="4800" b="1" dirty="0">
+                <a:solidFill>
+                  <a:srgbClr val="AF1F24"/>
+                </a:solidFill>
+                <a:latin typeface="Source Han Sans SC" pitchFamily="34" charset="0"/>
+                <a:ea typeface="Source Han Sans SC" pitchFamily="34" charset="-122"/>
+                <a:cs typeface="Source Han Sans SC" pitchFamily="34" charset="-120"/>
+              </a:rPr>
+              <a:t>01</a:t>
+            </a:r>
+            <a:endParaRPr lang="en-US" sz="4800" dirty="0"/>
           </a:p>
         </p:txBody>
       </p:sp>
@@ -1809,115 +2277,8 @@
         </p:nvSpPr>
         <p:spPr>
           <a:xfrm>
-            <a:off x="640080" y="1371600"/>
-            <a:ext cx="10789920" cy="3840480"/>
-          </a:xfrm>
-          <a:prstGeom prst="rect">
-            <a:avLst/>
-          </a:prstGeom>
-          <a:noFill/>
-          <a:ln/>
-        </p:spPr>
-        <p:txBody>
-          <a:bodyPr wrap="square" lIns="0" tIns="0" rIns="0" bIns="0" rtlCol="0" anchor="ctr"/>
-          <a:lstStyle/>
-          <a:p>
-            <a:pPr marL="342900" indent="-342900">
-              <a:spcAft>
-                <a:spcPts val="800"/>
-              </a:spcAft>
-              <a:buSzPct val="100000"/>
-              <a:buChar char="•"/>
-            </a:pPr>
-            <a:r>
-              <a:rPr lang="en-US" sz="1800" dirty="0">
-                <a:solidFill>
-                  <a:srgbClr val="171717"/>
-                </a:solidFill>
-                <a:latin typeface="Source Han Sans SC" pitchFamily="34" charset="0"/>
-                <a:ea typeface="Source Han Sans SC" pitchFamily="34" charset="-122"/>
-                <a:cs typeface="Source Han Sans SC" pitchFamily="34" charset="-120"/>
-              </a:rPr>
-              <a:t>统一纳管异构算力资源，支持按项目配额与审计</a:t>
-            </a:r>
-            <a:endParaRPr lang="en-US" sz="1800" dirty="0"/>
-          </a:p>
-          <a:p>
-            <a:pPr marL="342900" indent="-342900">
-              <a:spcAft>
-                <a:spcPts val="800"/>
-              </a:spcAft>
-              <a:buSzPct val="100000"/>
-              <a:buChar char="•"/>
-            </a:pPr>
-            <a:r>
-              <a:rPr lang="en-US" sz="1800" dirty="0">
-                <a:solidFill>
-                  <a:srgbClr val="171717"/>
-                </a:solidFill>
-                <a:latin typeface="Source Han Sans SC" pitchFamily="34" charset="0"/>
-                <a:ea typeface="Source Han Sans SC" pitchFamily="34" charset="-122"/>
-                <a:cs typeface="Source Han Sans SC" pitchFamily="34" charset="-120"/>
-              </a:rPr>
-              <a:t>监控告警与工单闭环，平均故障响应时长下降</a:t>
-            </a:r>
-            <a:endParaRPr lang="en-US" sz="1800" dirty="0"/>
-          </a:p>
-          <a:p>
-            <a:pPr marL="342900" indent="-342900">
-              <a:spcAft>
-                <a:spcPts val="800"/>
-              </a:spcAft>
-              <a:buSzPct val="100000"/>
-              <a:buChar char="•"/>
-            </a:pPr>
-            <a:r>
-              <a:rPr lang="en-US" sz="1800" dirty="0">
-                <a:solidFill>
-                  <a:srgbClr val="171717"/>
-                </a:solidFill>
-                <a:latin typeface="Source Han Sans SC" pitchFamily="34" charset="0"/>
-                <a:ea typeface="Source Han Sans SC" pitchFamily="34" charset="-122"/>
-                <a:cs typeface="Source Han Sans SC" pitchFamily="34" charset="-120"/>
-              </a:rPr>
-              <a:t>提供标准 API，便于业务系统集成</a:t>
-            </a:r>
-            <a:endParaRPr lang="en-US" sz="1800" dirty="0"/>
-          </a:p>
-        </p:txBody>
-      </p:sp>
-      <p:sp>
-        <p:nvSpPr>
-          <p:cNvPr id="6" name="Shape 3"/>
-          <p:cNvSpPr/>
-          <p:nvPr/>
-        </p:nvSpPr>
-        <p:spPr>
-          <a:xfrm>
-            <a:off x="502920" y="5623560"/>
-            <a:ext cx="11155680" cy="640080"/>
-          </a:xfrm>
-          <a:prstGeom prst="roundRect">
-            <a:avLst>
-              <a:gd name="adj" fmla="val 11429"/>
-            </a:avLst>
-          </a:prstGeom>
-          <a:solidFill>
-            <a:srgbClr val="F4F4F5"/>
-          </a:solidFill>
-          <a:ln/>
-        </p:spPr>
-      </p:sp>
-      <p:sp>
-        <p:nvSpPr>
-          <p:cNvPr id="7" name="Text 4"/>
-          <p:cNvSpPr/>
-          <p:nvPr/>
-        </p:nvSpPr>
-        <p:spPr>
-          <a:xfrm>
-            <a:off x="640080" y="5715000"/>
-            <a:ext cx="10881360" cy="457200"/>
+            <a:off x="594360" y="2971800"/>
+            <a:ext cx="8252231" cy="640080"/>
           </a:xfrm>
           <a:prstGeom prst="rect">
             <a:avLst/>
@@ -1933,30 +2294,50 @@
               <a:buNone/>
             </a:pPr>
             <a:r>
-              <a:rPr lang="en-US" sz="1200" dirty="0">
-                <a:solidFill>
-                  <a:srgbClr val="525252"/>
-                </a:solidFill>
-                <a:latin typeface="Source Han Sans SC" pitchFamily="34" charset="0"/>
-                <a:ea typeface="Source Han Sans SC" pitchFamily="34" charset="-122"/>
-                <a:cs typeface="Source Han Sans SC" pitchFamily="34" charset="-120"/>
-              </a:rPr>
-              <a:t>数据为样例占位，正式汇报请替换为真实指标。</a:t>
-            </a:r>
-            <a:endParaRPr lang="en-US" sz="1200" dirty="0"/>
-          </a:p>
-        </p:txBody>
-      </p:sp>
-      <p:sp>
-        <p:nvSpPr>
-          <p:cNvPr id="8" name="Text 5"/>
-          <p:cNvSpPr/>
-          <p:nvPr/>
-        </p:nvSpPr>
-        <p:spPr>
-          <a:xfrm>
-            <a:off x="457200" y="6492240"/>
-            <a:ext cx="7315200" cy="228600"/>
+              <a:rPr lang="en-US" sz="3200" b="1" dirty="0">
+                <a:solidFill>
+                  <a:srgbClr val="171717"/>
+                </a:solidFill>
+                <a:latin typeface="Source Han Sans SC" pitchFamily="34" charset="0"/>
+                <a:ea typeface="Source Han Sans SC" pitchFamily="34" charset="-122"/>
+                <a:cs typeface="Source Han Sans SC" pitchFamily="34" charset="-120"/>
+              </a:rPr>
+              <a:t>能力与进展</a:t>
+            </a:r>
+            <a:endParaRPr lang="en-US" sz="3200" dirty="0"/>
+          </a:p>
+        </p:txBody>
+      </p:sp>
+      <p:sp>
+        <p:nvSpPr>
+          <p:cNvPr id="6" name="Shape 3"/>
+          <p:cNvSpPr/>
+          <p:nvPr/>
+        </p:nvSpPr>
+        <p:spPr>
+          <a:xfrm>
+            <a:off x="594360" y="3749040"/>
+            <a:ext cx="1645920" cy="36576"/>
+          </a:xfrm>
+          <a:prstGeom prst="rect">
+            <a:avLst/>
+          </a:prstGeom>
+          <a:solidFill>
+            <a:srgbClr val="AF1F24"/>
+          </a:solidFill>
+          <a:ln/>
+        </p:spPr>
+      </p:sp>
+      <p:sp>
+        <p:nvSpPr>
+          <p:cNvPr id="7" name="Text 4"/>
+          <p:cNvSpPr/>
+          <p:nvPr/>
+        </p:nvSpPr>
+        <p:spPr>
+          <a:xfrm>
+            <a:off x="594360" y="6510528"/>
+            <a:ext cx="6400800" cy="201168"/>
           </a:xfrm>
           <a:prstGeom prst="rect">
             <a:avLst/>
@@ -1988,14 +2369,14 @@
       </p:sp>
       <p:sp>
         <p:nvSpPr>
-          <p:cNvPr id="9" name="Text 6"/>
-          <p:cNvSpPr/>
-          <p:nvPr/>
-        </p:nvSpPr>
-        <p:spPr>
-          <a:xfrm>
-            <a:off x="10515600" y="6492240"/>
-            <a:ext cx="1188720" cy="228600"/>
+          <p:cNvPr id="8" name="Text 5"/>
+          <p:cNvSpPr/>
+          <p:nvPr/>
+        </p:nvSpPr>
+        <p:spPr>
+          <a:xfrm>
+            <a:off x="10500055" y="6510528"/>
+            <a:ext cx="1097280" cy="201168"/>
           </a:xfrm>
           <a:prstGeom prst="rect">
             <a:avLst/>
@@ -2019,7 +2400,7 @@
                 <a:ea typeface="Source Han Sans SC" pitchFamily="34" charset="-122"/>
                 <a:cs typeface="Source Han Sans SC" pitchFamily="34" charset="-120"/>
               </a:rPr>
-              <a:t>3 / 5</a:t>
+              <a:t>3 / 7</a:t>
             </a:r>
             <a:endParaRPr lang="en-US" sz="1000" dirty="0"/>
           </a:p>
@@ -2050,29 +2431,9 @@
           <a:chExt cx="0" cy="0"/>
         </a:xfrm>
       </p:grpSpPr>
-      <p:sp>
-        <p:nvSpPr>
-          <p:cNvPr id="2" name="Shape 0"/>
-          <p:cNvSpPr/>
-          <p:nvPr/>
-        </p:nvSpPr>
-        <p:spPr>
-          <a:xfrm>
-            <a:off x="0" y="0"/>
-            <a:ext cx="109728" cy="6858000"/>
-          </a:xfrm>
-          <a:prstGeom prst="rect">
-            <a:avLst/>
-          </a:prstGeom>
-          <a:solidFill>
-            <a:srgbClr val="AF1F24"/>
-          </a:solidFill>
-          <a:ln/>
-        </p:spPr>
-      </p:sp>
       <p:pic>
         <p:nvPicPr>
-          <p:cNvPr id="3" name="Image 0" descr="/workspace/test02-work/repo/skills/sugon-ppt-template/assets/logo.png">    </p:cNvPr>
+          <p:cNvPr id="2" name="Image 0" descr="/workspace/test02-work/repo/skills/sugon-ppt-template/assets/logo.png">    </p:cNvPr>
           <p:cNvPicPr>
             <a:picLocks noChangeAspect="1"/>
           </p:cNvPicPr>
@@ -2086,8 +2447,8 @@
         </p:blipFill>
         <p:spPr>
           <a:xfrm>
-            <a:off x="10241280" y="320040"/>
-            <a:ext cx="1463040" cy="583815"/>
+            <a:off x="10180015" y="347472"/>
+            <a:ext cx="1417320" cy="565571"/>
           </a:xfrm>
           <a:prstGeom prst="rect">
             <a:avLst/>
@@ -2096,14 +2457,34 @@
       </p:pic>
       <p:sp>
         <p:nvSpPr>
+          <p:cNvPr id="3" name="Shape 0"/>
+          <p:cNvSpPr/>
+          <p:nvPr/>
+        </p:nvSpPr>
+        <p:spPr>
+          <a:xfrm>
+            <a:off x="594360" y="438912"/>
+            <a:ext cx="73152" cy="384048"/>
+          </a:xfrm>
+          <a:prstGeom prst="rect">
+            <a:avLst/>
+          </a:prstGeom>
+          <a:solidFill>
+            <a:srgbClr val="AF1F24"/>
+          </a:solidFill>
+          <a:ln/>
+        </p:spPr>
+      </p:sp>
+      <p:sp>
+        <p:nvSpPr>
           <p:cNvPr id="4" name="Text 1"/>
           <p:cNvSpPr/>
           <p:nvPr/>
         </p:nvSpPr>
         <p:spPr>
           <a:xfrm>
-            <a:off x="502920" y="365760"/>
-            <a:ext cx="9418320" cy="822960"/>
+            <a:off x="795528" y="347472"/>
+            <a:ext cx="9174175" cy="640080"/>
           </a:xfrm>
           <a:prstGeom prst="rect">
             <a:avLst/>
@@ -2119,7 +2500,7 @@
               <a:buNone/>
             </a:pPr>
             <a:r>
-              <a:rPr lang="en-US" sz="2400" b="1" dirty="0">
+              <a:rPr lang="en-US" sz="2600" b="1" dirty="0">
                 <a:solidFill>
                   <a:srgbClr val="171717"/>
                 </a:solidFill>
@@ -2127,22 +2508,64 @@
                 <a:ea typeface="Source Han Sans SC" pitchFamily="34" charset="-122"/>
                 <a:cs typeface="Source Han Sans SC" pitchFamily="34" charset="-120"/>
               </a:rPr>
-              <a:t>本季度三项落地进展按期完成</a:t>
-            </a:r>
-            <a:endParaRPr lang="en-US" sz="2400" dirty="0"/>
-          </a:p>
-        </p:txBody>
-      </p:sp>
-      <p:sp>
-        <p:nvSpPr>
-          <p:cNvPr id="5" name="Text 2"/>
-          <p:cNvSpPr/>
-          <p:nvPr/>
-        </p:nvSpPr>
-        <p:spPr>
-          <a:xfrm>
-            <a:off x="640080" y="1371600"/>
-            <a:ext cx="10789920" cy="3840480"/>
+              <a:t>统一调度已打通异构算力纳管与配额审计</a:t>
+            </a:r>
+            <a:endParaRPr lang="en-US" sz="2600" dirty="0"/>
+          </a:p>
+        </p:txBody>
+      </p:sp>
+      <p:sp>
+        <p:nvSpPr>
+          <p:cNvPr id="5" name="Shape 2"/>
+          <p:cNvSpPr/>
+          <p:nvPr/>
+        </p:nvSpPr>
+        <p:spPr>
+          <a:xfrm>
+            <a:off x="594360" y="1051560"/>
+            <a:ext cx="2194560" cy="32004"/>
+          </a:xfrm>
+          <a:prstGeom prst="rect">
+            <a:avLst/>
+          </a:prstGeom>
+          <a:solidFill>
+            <a:srgbClr val="AF1F24"/>
+          </a:solidFill>
+          <a:ln/>
+        </p:spPr>
+      </p:sp>
+      <p:sp>
+        <p:nvSpPr>
+          <p:cNvPr id="6" name="Shape 3"/>
+          <p:cNvSpPr/>
+          <p:nvPr/>
+        </p:nvSpPr>
+        <p:spPr>
+          <a:xfrm>
+            <a:off x="594360" y="1371600"/>
+            <a:ext cx="11002975" cy="3977640"/>
+          </a:xfrm>
+          <a:prstGeom prst="roundRect">
+            <a:avLst>
+              <a:gd name="adj" fmla="val 2299"/>
+            </a:avLst>
+          </a:prstGeom>
+          <a:solidFill>
+            <a:srgbClr val="F4F4F5"/>
+          </a:solidFill>
+          <a:ln/>
+        </p:spPr>
+      </p:sp>
+      <p:sp>
+        <p:nvSpPr>
+          <p:cNvPr id="7" name="Text 4"/>
+          <p:cNvSpPr/>
+          <p:nvPr/>
+        </p:nvSpPr>
+        <p:spPr>
+          <a:xfrm>
+            <a:off x="1005840" y="1737360"/>
+            <a:ext cx="10180015" cy="2926080"/>
           </a:xfrm>
           <a:prstGeom prst="rect">
             <a:avLst/>
@@ -2154,15 +2577,14 @@
           <a:bodyPr wrap="square" lIns="0" tIns="0" rIns="0" bIns="0" rtlCol="0" anchor="ctr"/>
           <a:lstStyle/>
           <a:p>
-            <a:pPr marL="342900" indent="-342900">
+            <a:pPr indent="0" marL="0">
               <a:spcAft>
-                <a:spcPts val="800"/>
+                <a:spcPts val="1400"/>
               </a:spcAft>
-              <a:buSzPct val="100000"/>
-              <a:buChar char="•"/>
-            </a:pPr>
-            <a:r>
-              <a:rPr lang="en-US" sz="1800" dirty="0">
+              <a:buNone/>
+            </a:pPr>
+            <a:r>
+              <a:rPr lang="en-US" sz="1600" dirty="0">
                 <a:solidFill>
                   <a:srgbClr val="171717"/>
                 </a:solidFill>
@@ -2170,20 +2592,19 @@
                 <a:ea typeface="Source Han Sans SC" pitchFamily="34" charset="-122"/>
                 <a:cs typeface="Source Han Sans SC" pitchFamily="34" charset="-120"/>
               </a:rPr>
-              <a:t>完成重点客户试点环境交付</a:t>
-            </a:r>
-            <a:endParaRPr lang="en-US" sz="1800" dirty="0"/>
-          </a:p>
-          <a:p>
-            <a:pPr marL="342900" indent="-342900">
+              <a:t>1.  按项目配额与审计追踪，满足内控与合规要求</a:t>
+            </a:r>
+            <a:endParaRPr lang="en-US" sz="1600" dirty="0"/>
+          </a:p>
+          <a:p>
+            <a:pPr indent="0" marL="0">
               <a:spcAft>
-                <a:spcPts val="800"/>
+                <a:spcPts val="1400"/>
               </a:spcAft>
-              <a:buSzPct val="100000"/>
-              <a:buChar char="•"/>
-            </a:pPr>
-            <a:r>
-              <a:rPr lang="en-US" sz="1800" dirty="0">
+              <a:buNone/>
+            </a:pPr>
+            <a:r>
+              <a:rPr lang="en-US" sz="1600" dirty="0">
                 <a:solidFill>
                   <a:srgbClr val="171717"/>
                 </a:solidFill>
@@ -2191,20 +2612,19 @@
                 <a:ea typeface="Source Han Sans SC" pitchFamily="34" charset="-122"/>
                 <a:cs typeface="Source Han Sans SC" pitchFamily="34" charset="-120"/>
               </a:rPr>
-              <a:t>内网技能与品牌规范可版本化复用</a:t>
-            </a:r>
-            <a:endParaRPr lang="en-US" sz="1800" dirty="0"/>
-          </a:p>
-          <a:p>
-            <a:pPr marL="342900" indent="-342900">
+              <a:t>2.  监控告警接入工单闭环，故障响应路径可度量</a:t>
+            </a:r>
+            <a:endParaRPr lang="en-US" sz="1600" dirty="0"/>
+          </a:p>
+          <a:p>
+            <a:pPr indent="0" marL="0">
               <a:spcAft>
-                <a:spcPts val="800"/>
+                <a:spcPts val="1400"/>
               </a:spcAft>
-              <a:buSzPct val="100000"/>
-              <a:buChar char="•"/>
-            </a:pPr>
-            <a:r>
-              <a:rPr lang="en-US" sz="1800" dirty="0">
+              <a:buNone/>
+            </a:pPr>
+            <a:r>
+              <a:rPr lang="en-US" sz="1600" dirty="0">
                 <a:solidFill>
                   <a:srgbClr val="171717"/>
                 </a:solidFill>
@@ -2212,22 +2632,22 @@
                 <a:ea typeface="Source Han Sans SC" pitchFamily="34" charset="-122"/>
                 <a:cs typeface="Source Han Sans SC" pitchFamily="34" charset="-120"/>
               </a:rPr>
-              <a:t>培训材料与操作手册已归档</a:t>
-            </a:r>
-            <a:endParaRPr lang="en-US" sz="1800" dirty="0"/>
-          </a:p>
-        </p:txBody>
-      </p:sp>
-      <p:sp>
-        <p:nvSpPr>
-          <p:cNvPr id="6" name="Text 3"/>
-          <p:cNvSpPr/>
-          <p:nvPr/>
-        </p:nvSpPr>
-        <p:spPr>
-          <a:xfrm>
-            <a:off x="457200" y="6492240"/>
-            <a:ext cx="7315200" cy="228600"/>
+              <a:t>3.  对外开放标准 API，业务系统可按周迭代接入</a:t>
+            </a:r>
+            <a:endParaRPr lang="en-US" sz="1600" dirty="0"/>
+          </a:p>
+        </p:txBody>
+      </p:sp>
+      <p:sp>
+        <p:nvSpPr>
+          <p:cNvPr id="8" name="Text 5"/>
+          <p:cNvSpPr/>
+          <p:nvPr/>
+        </p:nvSpPr>
+        <p:spPr>
+          <a:xfrm>
+            <a:off x="1005840" y="4754880"/>
+            <a:ext cx="10180015" cy="365760"/>
           </a:xfrm>
           <a:prstGeom prst="rect">
             <a:avLst/>
@@ -2243,6 +2663,45 @@
               <a:buNone/>
             </a:pPr>
             <a:r>
+              <a:rPr lang="en-US" sz="1200" dirty="0">
+                <a:solidFill>
+                  <a:srgbClr val="525252"/>
+                </a:solidFill>
+                <a:latin typeface="Source Han Sans SC" pitchFamily="34" charset="0"/>
+                <a:ea typeface="Source Han Sans SC" pitchFamily="34" charset="-122"/>
+                <a:cs typeface="Source Han Sans SC" pitchFamily="34" charset="-120"/>
+              </a:rPr>
+              <a:t>指标为样例占位，正式稿请替换为真实数据。</a:t>
+            </a:r>
+            <a:endParaRPr lang="en-US" sz="1200" dirty="0"/>
+          </a:p>
+        </p:txBody>
+      </p:sp>
+      <p:sp>
+        <p:nvSpPr>
+          <p:cNvPr id="9" name="Text 6"/>
+          <p:cNvSpPr/>
+          <p:nvPr/>
+        </p:nvSpPr>
+        <p:spPr>
+          <a:xfrm>
+            <a:off x="594360" y="6510528"/>
+            <a:ext cx="6400800" cy="201168"/>
+          </a:xfrm>
+          <a:prstGeom prst="rect">
+            <a:avLst/>
+          </a:prstGeom>
+          <a:noFill/>
+          <a:ln/>
+        </p:spPr>
+        <p:txBody>
+          <a:bodyPr wrap="square" lIns="0" tIns="0" rIns="0" bIns="0" rtlCol="0" anchor="ctr"/>
+          <a:lstStyle/>
+          <a:p>
+            <a:pPr indent="0" marL="0">
+              <a:buNone/>
+            </a:pPr>
+            <a:r>
               <a:rPr lang="en-US" sz="1000" dirty="0">
                 <a:solidFill>
                   <a:srgbClr val="525252"/>
@@ -2259,14 +2718,14 @@
       </p:sp>
       <p:sp>
         <p:nvSpPr>
-          <p:cNvPr id="7" name="Text 4"/>
-          <p:cNvSpPr/>
-          <p:nvPr/>
-        </p:nvSpPr>
-        <p:spPr>
-          <a:xfrm>
-            <a:off x="10515600" y="6492240"/>
-            <a:ext cx="1188720" cy="228600"/>
+          <p:cNvPr id="10" name="Text 7"/>
+          <p:cNvSpPr/>
+          <p:nvPr/>
+        </p:nvSpPr>
+        <p:spPr>
+          <a:xfrm>
+            <a:off x="10500055" y="6510528"/>
+            <a:ext cx="1097280" cy="201168"/>
           </a:xfrm>
           <a:prstGeom prst="rect">
             <a:avLst/>
@@ -2290,7 +2749,7 @@
                 <a:ea typeface="Source Han Sans SC" pitchFamily="34" charset="-122"/>
                 <a:cs typeface="Source Han Sans SC" pitchFamily="34" charset="-120"/>
               </a:rPr>
-              <a:t>4 / 5</a:t>
+              <a:t>4 / 7</a:t>
             </a:r>
             <a:endParaRPr lang="en-US" sz="1000" dirty="0"/>
           </a:p>
@@ -2321,49 +2780,9 @@
           <a:chExt cx="0" cy="0"/>
         </a:xfrm>
       </p:grpSpPr>
-      <p:sp>
-        <p:nvSpPr>
-          <p:cNvPr id="2" name="Shape 0"/>
-          <p:cNvSpPr/>
-          <p:nvPr/>
-        </p:nvSpPr>
-        <p:spPr>
-          <a:xfrm>
-            <a:off x="0" y="0"/>
-            <a:ext cx="12191695" cy="6858000"/>
-          </a:xfrm>
-          <a:prstGeom prst="rect">
-            <a:avLst/>
-          </a:prstGeom>
-          <a:solidFill>
-            <a:srgbClr val="FFFFFF"/>
-          </a:solidFill>
-          <a:ln/>
-        </p:spPr>
-      </p:sp>
-      <p:sp>
-        <p:nvSpPr>
-          <p:cNvPr id="3" name="Shape 1"/>
-          <p:cNvSpPr/>
-          <p:nvPr/>
-        </p:nvSpPr>
-        <p:spPr>
-          <a:xfrm>
-            <a:off x="0" y="0"/>
-            <a:ext cx="12191695" cy="182880"/>
-          </a:xfrm>
-          <a:prstGeom prst="rect">
-            <a:avLst/>
-          </a:prstGeom>
-          <a:solidFill>
-            <a:srgbClr val="AF1F24"/>
-          </a:solidFill>
-          <a:ln/>
-        </p:spPr>
-      </p:sp>
       <p:pic>
         <p:nvPicPr>
-          <p:cNvPr id="4" name="Image 0" descr="/workspace/test02-work/repo/skills/sugon-ppt-template/assets/logo.png">    </p:cNvPr>
+          <p:cNvPr id="2" name="Image 0" descr="/workspace/test02-work/repo/skills/sugon-ppt-template/assets/logo.png">    </p:cNvPr>
           <p:cNvPicPr>
             <a:picLocks noChangeAspect="1"/>
           </p:cNvPicPr>
@@ -2377,8 +2796,8 @@
         </p:blipFill>
         <p:spPr>
           <a:xfrm>
-            <a:off x="5349240" y="1828800"/>
-            <a:ext cx="1645920" cy="656792"/>
+            <a:off x="10180015" y="347472"/>
+            <a:ext cx="1417320" cy="565571"/>
           </a:xfrm>
           <a:prstGeom prst="rect">
             <a:avLst/>
@@ -2387,14 +2806,611 @@
       </p:pic>
       <p:sp>
         <p:nvSpPr>
-          <p:cNvPr id="5" name="Text 2"/>
-          <p:cNvSpPr/>
-          <p:nvPr/>
-        </p:nvSpPr>
-        <p:spPr>
-          <a:xfrm>
-            <a:off x="457200" y="3017520"/>
-            <a:ext cx="11247120" cy="731520"/>
+          <p:cNvPr id="3" name="Shape 0"/>
+          <p:cNvSpPr/>
+          <p:nvPr/>
+        </p:nvSpPr>
+        <p:spPr>
+          <a:xfrm>
+            <a:off x="594360" y="438912"/>
+            <a:ext cx="73152" cy="384048"/>
+          </a:xfrm>
+          <a:prstGeom prst="rect">
+            <a:avLst/>
+          </a:prstGeom>
+          <a:solidFill>
+            <a:srgbClr val="AF1F24"/>
+          </a:solidFill>
+          <a:ln/>
+        </p:spPr>
+      </p:sp>
+      <p:sp>
+        <p:nvSpPr>
+          <p:cNvPr id="4" name="Text 1"/>
+          <p:cNvSpPr/>
+          <p:nvPr/>
+        </p:nvSpPr>
+        <p:spPr>
+          <a:xfrm>
+            <a:off x="795528" y="347472"/>
+            <a:ext cx="9174175" cy="640080"/>
+          </a:xfrm>
+          <a:prstGeom prst="rect">
+            <a:avLst/>
+          </a:prstGeom>
+          <a:noFill/>
+          <a:ln/>
+        </p:spPr>
+        <p:txBody>
+          <a:bodyPr wrap="square" lIns="0" tIns="0" rIns="0" bIns="0" rtlCol="0" anchor="ctr"/>
+          <a:lstStyle/>
+          <a:p>
+            <a:pPr indent="0" marL="0">
+              <a:buNone/>
+            </a:pPr>
+            <a:r>
+              <a:rPr lang="en-US" sz="2600" b="1" dirty="0">
+                <a:solidFill>
+                  <a:srgbClr val="171717"/>
+                </a:solidFill>
+                <a:latin typeface="Source Han Sans SC" pitchFamily="34" charset="0"/>
+                <a:ea typeface="Source Han Sans SC" pitchFamily="34" charset="-122"/>
+                <a:cs typeface="Source Han Sans SC" pitchFamily="34" charset="-120"/>
+              </a:rPr>
+              <a:t>试点交付与规范沉淀同步推进</a:t>
+            </a:r>
+            <a:endParaRPr lang="en-US" sz="2600" dirty="0"/>
+          </a:p>
+        </p:txBody>
+      </p:sp>
+      <p:sp>
+        <p:nvSpPr>
+          <p:cNvPr id="5" name="Shape 2"/>
+          <p:cNvSpPr/>
+          <p:nvPr/>
+        </p:nvSpPr>
+        <p:spPr>
+          <a:xfrm>
+            <a:off x="594360" y="1051560"/>
+            <a:ext cx="2194560" cy="32004"/>
+          </a:xfrm>
+          <a:prstGeom prst="rect">
+            <a:avLst/>
+          </a:prstGeom>
+          <a:solidFill>
+            <a:srgbClr val="AF1F24"/>
+          </a:solidFill>
+          <a:ln/>
+        </p:spPr>
+      </p:sp>
+      <p:sp>
+        <p:nvSpPr>
+          <p:cNvPr id="6" name="Shape 3"/>
+          <p:cNvSpPr/>
+          <p:nvPr/>
+        </p:nvSpPr>
+        <p:spPr>
+          <a:xfrm>
+            <a:off x="594360" y="1371600"/>
+            <a:ext cx="5318608" cy="4023360"/>
+          </a:xfrm>
+          <a:prstGeom prst="roundRect">
+            <a:avLst>
+              <a:gd name="adj" fmla="val 2273"/>
+            </a:avLst>
+          </a:prstGeom>
+          <a:solidFill>
+            <a:srgbClr val="F4F4F5"/>
+          </a:solidFill>
+          <a:ln/>
+        </p:spPr>
+      </p:sp>
+      <p:sp>
+        <p:nvSpPr>
+          <p:cNvPr id="7" name="Shape 4"/>
+          <p:cNvSpPr/>
+          <p:nvPr/>
+        </p:nvSpPr>
+        <p:spPr>
+          <a:xfrm>
+            <a:off x="914400" y="1737360"/>
+            <a:ext cx="822960" cy="36576"/>
+          </a:xfrm>
+          <a:prstGeom prst="rect">
+            <a:avLst/>
+          </a:prstGeom>
+          <a:solidFill>
+            <a:srgbClr val="AF1F24"/>
+          </a:solidFill>
+          <a:ln/>
+        </p:spPr>
+      </p:sp>
+      <p:sp>
+        <p:nvSpPr>
+          <p:cNvPr id="8" name="Text 5"/>
+          <p:cNvSpPr/>
+          <p:nvPr/>
+        </p:nvSpPr>
+        <p:spPr>
+          <a:xfrm>
+            <a:off x="914400" y="1874520"/>
+            <a:ext cx="4678528" cy="411480"/>
+          </a:xfrm>
+          <a:prstGeom prst="rect">
+            <a:avLst/>
+          </a:prstGeom>
+          <a:noFill/>
+          <a:ln/>
+        </p:spPr>
+        <p:txBody>
+          <a:bodyPr wrap="square" lIns="0" tIns="0" rIns="0" bIns="0" rtlCol="0" anchor="ctr"/>
+          <a:lstStyle/>
+          <a:p>
+            <a:pPr indent="0" marL="0">
+              <a:buNone/>
+            </a:pPr>
+            <a:r>
+              <a:rPr lang="en-US" sz="1800" b="1" dirty="0">
+                <a:solidFill>
+                  <a:srgbClr val="171717"/>
+                </a:solidFill>
+                <a:latin typeface="Source Han Sans SC" pitchFamily="34" charset="0"/>
+                <a:ea typeface="Source Han Sans SC" pitchFamily="34" charset="-122"/>
+                <a:cs typeface="Source Han Sans SC" pitchFamily="34" charset="-120"/>
+              </a:rPr>
+              <a:t>试点交付</a:t>
+            </a:r>
+            <a:endParaRPr lang="en-US" sz="1800" dirty="0"/>
+          </a:p>
+        </p:txBody>
+      </p:sp>
+      <p:sp>
+        <p:nvSpPr>
+          <p:cNvPr id="9" name="Text 6"/>
+          <p:cNvSpPr/>
+          <p:nvPr/>
+        </p:nvSpPr>
+        <p:spPr>
+          <a:xfrm>
+            <a:off x="914400" y="2514600"/>
+            <a:ext cx="4678528" cy="2560320"/>
+          </a:xfrm>
+          <a:prstGeom prst="rect">
+            <a:avLst/>
+          </a:prstGeom>
+          <a:noFill/>
+          <a:ln/>
+        </p:spPr>
+        <p:txBody>
+          <a:bodyPr wrap="square" lIns="0" tIns="0" rIns="0" bIns="0" rtlCol="0" anchor="ctr"/>
+          <a:lstStyle/>
+          <a:p>
+            <a:pPr marL="342900" indent="-342900">
+              <a:spcAft>
+                <a:spcPts val="1200"/>
+              </a:spcAft>
+              <a:buSzPct val="100000"/>
+              <a:buChar char="•"/>
+            </a:pPr>
+            <a:r>
+              <a:rPr lang="en-US" sz="1500" dirty="0">
+                <a:solidFill>
+                  <a:srgbClr val="171717"/>
+                </a:solidFill>
+                <a:latin typeface="Source Han Sans SC" pitchFamily="34" charset="0"/>
+                <a:ea typeface="Source Han Sans SC" pitchFamily="34" charset="-122"/>
+                <a:cs typeface="Source Han Sans SC" pitchFamily="34" charset="-120"/>
+              </a:rPr>
+              <a:t>重点客户环境已上线试运行</a:t>
+            </a:r>
+            <a:endParaRPr lang="en-US" sz="1500" dirty="0"/>
+          </a:p>
+          <a:p>
+            <a:pPr marL="342900" indent="-342900">
+              <a:spcAft>
+                <a:spcPts val="1200"/>
+              </a:spcAft>
+              <a:buSzPct val="100000"/>
+              <a:buChar char="•"/>
+            </a:pPr>
+            <a:r>
+              <a:rPr lang="en-US" sz="1500" dirty="0">
+                <a:solidFill>
+                  <a:srgbClr val="171717"/>
+                </a:solidFill>
+                <a:latin typeface="Source Han Sans SC" pitchFamily="34" charset="0"/>
+                <a:ea typeface="Source Han Sans SC" pitchFamily="34" charset="-122"/>
+                <a:cs typeface="Source Han Sans SC" pitchFamily="34" charset="-120"/>
+              </a:rPr>
+              <a:t>操作手册与培训材料完成归档</a:t>
+            </a:r>
+            <a:endParaRPr lang="en-US" sz="1500" dirty="0"/>
+          </a:p>
+        </p:txBody>
+      </p:sp>
+      <p:sp>
+        <p:nvSpPr>
+          <p:cNvPr id="10" name="Shape 7"/>
+          <p:cNvSpPr/>
+          <p:nvPr/>
+        </p:nvSpPr>
+        <p:spPr>
+          <a:xfrm>
+            <a:off x="6278728" y="1371600"/>
+            <a:ext cx="5318608" cy="4023360"/>
+          </a:xfrm>
+          <a:prstGeom prst="roundRect">
+            <a:avLst>
+              <a:gd name="adj" fmla="val 2273"/>
+            </a:avLst>
+          </a:prstGeom>
+          <a:solidFill>
+            <a:srgbClr val="F4F4F5"/>
+          </a:solidFill>
+          <a:ln/>
+        </p:spPr>
+      </p:sp>
+      <p:sp>
+        <p:nvSpPr>
+          <p:cNvPr id="11" name="Shape 8"/>
+          <p:cNvSpPr/>
+          <p:nvPr/>
+        </p:nvSpPr>
+        <p:spPr>
+          <a:xfrm>
+            <a:off x="6598768" y="1737360"/>
+            <a:ext cx="822960" cy="36576"/>
+          </a:xfrm>
+          <a:prstGeom prst="rect">
+            <a:avLst/>
+          </a:prstGeom>
+          <a:solidFill>
+            <a:srgbClr val="AF1F24"/>
+          </a:solidFill>
+          <a:ln/>
+        </p:spPr>
+      </p:sp>
+      <p:sp>
+        <p:nvSpPr>
+          <p:cNvPr id="12" name="Text 9"/>
+          <p:cNvSpPr/>
+          <p:nvPr/>
+        </p:nvSpPr>
+        <p:spPr>
+          <a:xfrm>
+            <a:off x="6598768" y="1874520"/>
+            <a:ext cx="4678528" cy="411480"/>
+          </a:xfrm>
+          <a:prstGeom prst="rect">
+            <a:avLst/>
+          </a:prstGeom>
+          <a:noFill/>
+          <a:ln/>
+        </p:spPr>
+        <p:txBody>
+          <a:bodyPr wrap="square" lIns="0" tIns="0" rIns="0" bIns="0" rtlCol="0" anchor="ctr"/>
+          <a:lstStyle/>
+          <a:p>
+            <a:pPr indent="0" marL="0">
+              <a:buNone/>
+            </a:pPr>
+            <a:r>
+              <a:rPr lang="en-US" sz="1800" b="1" dirty="0">
+                <a:solidFill>
+                  <a:srgbClr val="171717"/>
+                </a:solidFill>
+                <a:latin typeface="Source Han Sans SC" pitchFamily="34" charset="0"/>
+                <a:ea typeface="Source Han Sans SC" pitchFamily="34" charset="-122"/>
+                <a:cs typeface="Source Han Sans SC" pitchFamily="34" charset="-120"/>
+              </a:rPr>
+              <a:t>规范沉淀</a:t>
+            </a:r>
+            <a:endParaRPr lang="en-US" sz="1800" dirty="0"/>
+          </a:p>
+        </p:txBody>
+      </p:sp>
+      <p:sp>
+        <p:nvSpPr>
+          <p:cNvPr id="13" name="Text 10"/>
+          <p:cNvSpPr/>
+          <p:nvPr/>
+        </p:nvSpPr>
+        <p:spPr>
+          <a:xfrm>
+            <a:off x="6598768" y="2514600"/>
+            <a:ext cx="4678528" cy="2560320"/>
+          </a:xfrm>
+          <a:prstGeom prst="rect">
+            <a:avLst/>
+          </a:prstGeom>
+          <a:noFill/>
+          <a:ln/>
+        </p:spPr>
+        <p:txBody>
+          <a:bodyPr wrap="square" lIns="0" tIns="0" rIns="0" bIns="0" rtlCol="0" anchor="ctr"/>
+          <a:lstStyle/>
+          <a:p>
+            <a:pPr marL="342900" indent="-342900">
+              <a:spcAft>
+                <a:spcPts val="1200"/>
+              </a:spcAft>
+              <a:buSzPct val="100000"/>
+              <a:buChar char="•"/>
+            </a:pPr>
+            <a:r>
+              <a:rPr lang="en-US" sz="1500" dirty="0">
+                <a:solidFill>
+                  <a:srgbClr val="171717"/>
+                </a:solidFill>
+                <a:latin typeface="Source Han Sans SC" pitchFamily="34" charset="0"/>
+                <a:ea typeface="Source Han Sans SC" pitchFamily="34" charset="-122"/>
+                <a:cs typeface="Source Han Sans SC" pitchFamily="34" charset="-120"/>
+              </a:rPr>
+              <a:t>品牌与 logo 规则可版本化安装</a:t>
+            </a:r>
+            <a:endParaRPr lang="en-US" sz="1500" dirty="0"/>
+          </a:p>
+          <a:p>
+            <a:pPr marL="342900" indent="-342900">
+              <a:spcAft>
+                <a:spcPts val="1200"/>
+              </a:spcAft>
+              <a:buSzPct val="100000"/>
+              <a:buChar char="•"/>
+            </a:pPr>
+            <a:r>
+              <a:rPr lang="en-US" sz="1500" dirty="0">
+                <a:solidFill>
+                  <a:srgbClr val="171717"/>
+                </a:solidFill>
+                <a:latin typeface="Source Han Sans SC" pitchFamily="34" charset="0"/>
+                <a:ea typeface="Source Han Sans SC" pitchFamily="34" charset="-122"/>
+                <a:cs typeface="Source Han Sans SC" pitchFamily="34" charset="-120"/>
+              </a:rPr>
+              <a:t>汇报模板统一 16:9 与识别色</a:t>
+            </a:r>
+            <a:endParaRPr lang="en-US" sz="1500" dirty="0"/>
+          </a:p>
+        </p:txBody>
+      </p:sp>
+      <p:sp>
+        <p:nvSpPr>
+          <p:cNvPr id="14" name="Text 11"/>
+          <p:cNvSpPr/>
+          <p:nvPr/>
+        </p:nvSpPr>
+        <p:spPr>
+          <a:xfrm>
+            <a:off x="594360" y="6510528"/>
+            <a:ext cx="6400800" cy="201168"/>
+          </a:xfrm>
+          <a:prstGeom prst="rect">
+            <a:avLst/>
+          </a:prstGeom>
+          <a:noFill/>
+          <a:ln/>
+        </p:spPr>
+        <p:txBody>
+          <a:bodyPr wrap="square" lIns="0" tIns="0" rIns="0" bIns="0" rtlCol="0" anchor="ctr"/>
+          <a:lstStyle/>
+          <a:p>
+            <a:pPr indent="0" marL="0">
+              <a:buNone/>
+            </a:pPr>
+            <a:r>
+              <a:rPr lang="en-US" sz="1000" dirty="0">
+                <a:solidFill>
+                  <a:srgbClr val="525252"/>
+                </a:solidFill>
+                <a:latin typeface="Source Han Sans SC" pitchFamily="34" charset="0"/>
+                <a:ea typeface="Source Han Sans SC" pitchFamily="34" charset="-122"/>
+                <a:cs typeface="Source Han Sans SC" pitchFamily="34" charset="-120"/>
+              </a:rPr>
+              <a:t>内部资料 · 注意保密</a:t>
+            </a:r>
+            <a:endParaRPr lang="en-US" sz="1000" dirty="0"/>
+          </a:p>
+        </p:txBody>
+      </p:sp>
+      <p:sp>
+        <p:nvSpPr>
+          <p:cNvPr id="15" name="Text 12"/>
+          <p:cNvSpPr/>
+          <p:nvPr/>
+        </p:nvSpPr>
+        <p:spPr>
+          <a:xfrm>
+            <a:off x="10500055" y="6510528"/>
+            <a:ext cx="1097280" cy="201168"/>
+          </a:xfrm>
+          <a:prstGeom prst="rect">
+            <a:avLst/>
+          </a:prstGeom>
+          <a:noFill/>
+          <a:ln/>
+        </p:spPr>
+        <p:txBody>
+          <a:bodyPr wrap="square" lIns="0" tIns="0" rIns="0" bIns="0" rtlCol="0" anchor="ctr"/>
+          <a:lstStyle/>
+          <a:p>
+            <a:pPr algn="r" indent="0" marL="0">
+              <a:buNone/>
+            </a:pPr>
+            <a:r>
+              <a:rPr lang="en-US" sz="1000" dirty="0">
+                <a:solidFill>
+                  <a:srgbClr val="525252"/>
+                </a:solidFill>
+                <a:latin typeface="Source Han Sans SC" pitchFamily="34" charset="0"/>
+                <a:ea typeface="Source Han Sans SC" pitchFamily="34" charset="-122"/>
+                <a:cs typeface="Source Han Sans SC" pitchFamily="34" charset="-120"/>
+              </a:rPr>
+              <a:t>5 / 7</a:t>
+            </a:r>
+            <a:endParaRPr lang="en-US" sz="1000" dirty="0"/>
+          </a:p>
+        </p:txBody>
+      </p:sp>
+    </p:spTree>
+  </p:cSld>
+  <p:clrMapOvr>
+    <a:masterClrMapping/>
+  </p:clrMapOvr>
+</p:sld>
+</file>
+
+<file path=ppt/slides/slide6.xml><?xml version="1.0" encoding="utf-8"?>
+<p:sld xmlns:a="http://schemas.openxmlformats.org/drawingml/2006/main" xmlns:r="http://schemas.openxmlformats.org/officeDocument/2006/relationships" xmlns:p="http://schemas.openxmlformats.org/presentationml/2006/main">
+  <p:cSld name="Slide 6">
+    <p:spTree>
+      <p:nvGrpSpPr>
+        <p:cNvPr id="1" name=""/>
+        <p:cNvGrpSpPr/>
+        <p:nvPr/>
+      </p:nvGrpSpPr>
+      <p:grpSpPr>
+        <a:xfrm>
+          <a:off x="0" y="0"/>
+          <a:ext cx="0" cy="0"/>
+          <a:chOff x="0" y="0"/>
+          <a:chExt cx="0" cy="0"/>
+        </a:xfrm>
+      </p:grpSpPr>
+      <p:pic>
+        <p:nvPicPr>
+          <p:cNvPr id="2" name="Image 0" descr="/workspace/test02-work/repo/skills/sugon-ppt-template/assets/logo.png">    </p:cNvPr>
+          <p:cNvPicPr>
+            <a:picLocks noChangeAspect="1"/>
+          </p:cNvPicPr>
+          <p:nvPr/>
+        </p:nvPicPr>
+        <p:blipFill>
+          <a:blip r:embed="rId1"/>
+          <a:stretch>
+            <a:fillRect/>
+          </a:stretch>
+        </p:blipFill>
+        <p:spPr>
+          <a:xfrm>
+            <a:off x="10180015" y="347472"/>
+            <a:ext cx="1417320" cy="565571"/>
+          </a:xfrm>
+          <a:prstGeom prst="rect">
+            <a:avLst/>
+          </a:prstGeom>
+        </p:spPr>
+      </p:pic>
+      <p:sp>
+        <p:nvSpPr>
+          <p:cNvPr id="3" name="Shape 0"/>
+          <p:cNvSpPr/>
+          <p:nvPr/>
+        </p:nvSpPr>
+        <p:spPr>
+          <a:xfrm>
+            <a:off x="594360" y="438912"/>
+            <a:ext cx="73152" cy="384048"/>
+          </a:xfrm>
+          <a:prstGeom prst="rect">
+            <a:avLst/>
+          </a:prstGeom>
+          <a:solidFill>
+            <a:srgbClr val="AF1F24"/>
+          </a:solidFill>
+          <a:ln/>
+        </p:spPr>
+      </p:sp>
+      <p:sp>
+        <p:nvSpPr>
+          <p:cNvPr id="4" name="Text 1"/>
+          <p:cNvSpPr/>
+          <p:nvPr/>
+        </p:nvSpPr>
+        <p:spPr>
+          <a:xfrm>
+            <a:off x="795528" y="347472"/>
+            <a:ext cx="9174175" cy="640080"/>
+          </a:xfrm>
+          <a:prstGeom prst="rect">
+            <a:avLst/>
+          </a:prstGeom>
+          <a:noFill/>
+          <a:ln/>
+        </p:spPr>
+        <p:txBody>
+          <a:bodyPr wrap="square" lIns="0" tIns="0" rIns="0" bIns="0" rtlCol="0" anchor="ctr"/>
+          <a:lstStyle/>
+          <a:p>
+            <a:pPr indent="0" marL="0">
+              <a:buNone/>
+            </a:pPr>
+            <a:r>
+              <a:rPr lang="en-US" sz="2600" b="1" dirty="0">
+                <a:solidFill>
+                  <a:srgbClr val="171717"/>
+                </a:solidFill>
+                <a:latin typeface="Source Han Sans SC" pitchFamily="34" charset="0"/>
+                <a:ea typeface="Source Han Sans SC" pitchFamily="34" charset="-122"/>
+                <a:cs typeface="Source Han Sans SC" pitchFamily="34" charset="-120"/>
+              </a:rPr>
+              <a:t>三项关键结果支撑本轮汇报结论</a:t>
+            </a:r>
+            <a:endParaRPr lang="en-US" sz="2600" dirty="0"/>
+          </a:p>
+        </p:txBody>
+      </p:sp>
+      <p:sp>
+        <p:nvSpPr>
+          <p:cNvPr id="5" name="Shape 2"/>
+          <p:cNvSpPr/>
+          <p:nvPr/>
+        </p:nvSpPr>
+        <p:spPr>
+          <a:xfrm>
+            <a:off x="594360" y="1051560"/>
+            <a:ext cx="2194560" cy="32004"/>
+          </a:xfrm>
+          <a:prstGeom prst="rect">
+            <a:avLst/>
+          </a:prstGeom>
+          <a:solidFill>
+            <a:srgbClr val="AF1F24"/>
+          </a:solidFill>
+          <a:ln/>
+        </p:spPr>
+      </p:sp>
+      <p:sp>
+        <p:nvSpPr>
+          <p:cNvPr id="6" name="Shape 3"/>
+          <p:cNvSpPr/>
+          <p:nvPr/>
+        </p:nvSpPr>
+        <p:spPr>
+          <a:xfrm>
+            <a:off x="594360" y="1828800"/>
+            <a:ext cx="3423818" cy="3200400"/>
+          </a:xfrm>
+          <a:prstGeom prst="roundRect">
+            <a:avLst>
+              <a:gd name="adj" fmla="val 2857"/>
+            </a:avLst>
+          </a:prstGeom>
+          <a:solidFill>
+            <a:srgbClr val="F4F4F5"/>
+          </a:solidFill>
+          <a:ln/>
+        </p:spPr>
+      </p:sp>
+      <p:sp>
+        <p:nvSpPr>
+          <p:cNvPr id="7" name="Text 4"/>
+          <p:cNvSpPr/>
+          <p:nvPr/>
+        </p:nvSpPr>
+        <p:spPr>
+          <a:xfrm>
+            <a:off x="777240" y="2331720"/>
+            <a:ext cx="3058058" cy="1097280"/>
           </a:xfrm>
           <a:prstGeom prst="rect">
             <a:avLst/>
@@ -2410,30 +3426,30 @@
               <a:buNone/>
             </a:pPr>
             <a:r>
-              <a:rPr lang="en-US" sz="3600" b="1" dirty="0">
-                <a:solidFill>
-                  <a:srgbClr val="171717"/>
-                </a:solidFill>
-                <a:latin typeface="Source Han Sans SC" pitchFamily="34" charset="0"/>
-                <a:ea typeface="Source Han Sans SC" pitchFamily="34" charset="-122"/>
-                <a:cs typeface="Source Han Sans SC" pitchFamily="34" charset="-120"/>
-              </a:rPr>
-              <a:t>谢谢 · 请指正</a:t>
-            </a:r>
-            <a:endParaRPr lang="en-US" sz="3600" dirty="0"/>
-          </a:p>
-        </p:txBody>
-      </p:sp>
-      <p:sp>
-        <p:nvSpPr>
-          <p:cNvPr id="6" name="Text 3"/>
-          <p:cNvSpPr/>
-          <p:nvPr/>
-        </p:nvSpPr>
-        <p:spPr>
-          <a:xfrm>
-            <a:off x="457200" y="3931920"/>
-            <a:ext cx="11247120" cy="365760"/>
+              <a:rPr lang="en-US" sz="4400" b="1" dirty="0">
+                <a:solidFill>
+                  <a:srgbClr val="AF1F24"/>
+                </a:solidFill>
+                <a:latin typeface="Source Han Sans SC" pitchFamily="34" charset="0"/>
+                <a:ea typeface="Source Han Sans SC" pitchFamily="34" charset="-122"/>
+                <a:cs typeface="Source Han Sans SC" pitchFamily="34" charset="-120"/>
+              </a:rPr>
+              <a:t>3</a:t>
+            </a:r>
+            <a:endParaRPr lang="en-US" sz="4400" dirty="0"/>
+          </a:p>
+        </p:txBody>
+      </p:sp>
+      <p:sp>
+        <p:nvSpPr>
+          <p:cNvPr id="8" name="Text 5"/>
+          <p:cNvSpPr/>
+          <p:nvPr/>
+        </p:nvSpPr>
+        <p:spPr>
+          <a:xfrm>
+            <a:off x="822960" y="3611880"/>
+            <a:ext cx="2966618" cy="822960"/>
           </a:xfrm>
           <a:prstGeom prst="rect">
             <a:avLst/>
@@ -2449,30 +3465,230 @@
               <a:buNone/>
             </a:pPr>
             <a:r>
-              <a:rPr lang="en-US" sz="1600" dirty="0">
-                <a:solidFill>
-                  <a:srgbClr val="525252"/>
-                </a:solidFill>
-                <a:latin typeface="Source Han Sans SC" pitchFamily="34" charset="0"/>
-                <a:ea typeface="Source Han Sans SC" pitchFamily="34" charset="-122"/>
-                <a:cs typeface="Source Han Sans SC" pitchFamily="34" charset="-120"/>
-              </a:rPr>
-              <a:t>曙光云</a:t>
-            </a:r>
-            <a:endParaRPr lang="en-US" sz="1600" dirty="0"/>
-          </a:p>
-        </p:txBody>
-      </p:sp>
-      <p:sp>
-        <p:nvSpPr>
-          <p:cNvPr id="7" name="Text 4"/>
-          <p:cNvSpPr/>
-          <p:nvPr/>
-        </p:nvSpPr>
-        <p:spPr>
-          <a:xfrm>
-            <a:off x="457200" y="6492240"/>
-            <a:ext cx="7315200" cy="228600"/>
+              <a:rPr lang="en-US" sz="1500" dirty="0">
+                <a:solidFill>
+                  <a:srgbClr val="171717"/>
+                </a:solidFill>
+                <a:latin typeface="Source Han Sans SC" pitchFamily="34" charset="0"/>
+                <a:ea typeface="Source Han Sans SC" pitchFamily="34" charset="-122"/>
+                <a:cs typeface="Source Han Sans SC" pitchFamily="34" charset="-120"/>
+              </a:rPr>
+              <a:t>重点试点已交付</a:t>
+            </a:r>
+            <a:endParaRPr lang="en-US" sz="1500" dirty="0"/>
+          </a:p>
+        </p:txBody>
+      </p:sp>
+      <p:sp>
+        <p:nvSpPr>
+          <p:cNvPr id="9" name="Shape 6"/>
+          <p:cNvSpPr/>
+          <p:nvPr/>
+        </p:nvSpPr>
+        <p:spPr>
+          <a:xfrm>
+            <a:off x="4383938" y="1828800"/>
+            <a:ext cx="3423818" cy="3200400"/>
+          </a:xfrm>
+          <a:prstGeom prst="roundRect">
+            <a:avLst>
+              <a:gd name="adj" fmla="val 2857"/>
+            </a:avLst>
+          </a:prstGeom>
+          <a:solidFill>
+            <a:srgbClr val="F4F4F5"/>
+          </a:solidFill>
+          <a:ln/>
+        </p:spPr>
+      </p:sp>
+      <p:sp>
+        <p:nvSpPr>
+          <p:cNvPr id="10" name="Text 7"/>
+          <p:cNvSpPr/>
+          <p:nvPr/>
+        </p:nvSpPr>
+        <p:spPr>
+          <a:xfrm>
+            <a:off x="4566818" y="2331720"/>
+            <a:ext cx="3058058" cy="1097280"/>
+          </a:xfrm>
+          <a:prstGeom prst="rect">
+            <a:avLst/>
+          </a:prstGeom>
+          <a:noFill/>
+          <a:ln/>
+        </p:spPr>
+        <p:txBody>
+          <a:bodyPr wrap="square" lIns="0" tIns="0" rIns="0" bIns="0" rtlCol="0" anchor="ctr"/>
+          <a:lstStyle/>
+          <a:p>
+            <a:pPr algn="ctr" indent="0" marL="0">
+              <a:buNone/>
+            </a:pPr>
+            <a:r>
+              <a:rPr lang="en-US" sz="4400" b="1" dirty="0">
+                <a:solidFill>
+                  <a:srgbClr val="AF1F24"/>
+                </a:solidFill>
+                <a:latin typeface="Source Han Sans SC" pitchFamily="34" charset="0"/>
+                <a:ea typeface="Source Han Sans SC" pitchFamily="34" charset="-122"/>
+                <a:cs typeface="Source Han Sans SC" pitchFamily="34" charset="-120"/>
+              </a:rPr>
+              <a:t>4</a:t>
+            </a:r>
+            <a:endParaRPr lang="en-US" sz="4400" dirty="0"/>
+          </a:p>
+        </p:txBody>
+      </p:sp>
+      <p:sp>
+        <p:nvSpPr>
+          <p:cNvPr id="11" name="Text 8"/>
+          <p:cNvSpPr/>
+          <p:nvPr/>
+        </p:nvSpPr>
+        <p:spPr>
+          <a:xfrm>
+            <a:off x="4612538" y="3611880"/>
+            <a:ext cx="2966618" cy="822960"/>
+          </a:xfrm>
+          <a:prstGeom prst="rect">
+            <a:avLst/>
+          </a:prstGeom>
+          <a:noFill/>
+          <a:ln/>
+        </p:spPr>
+        <p:txBody>
+          <a:bodyPr wrap="square" lIns="0" tIns="0" rIns="0" bIns="0" rtlCol="0" anchor="ctr"/>
+          <a:lstStyle/>
+          <a:p>
+            <a:pPr algn="ctr" indent="0" marL="0">
+              <a:buNone/>
+            </a:pPr>
+            <a:r>
+              <a:rPr lang="en-US" sz="1500" dirty="0">
+                <a:solidFill>
+                  <a:srgbClr val="171717"/>
+                </a:solidFill>
+                <a:latin typeface="Source Han Sans SC" pitchFamily="34" charset="0"/>
+                <a:ea typeface="Source Han Sans SC" pitchFamily="34" charset="-122"/>
+                <a:cs typeface="Source Han Sans SC" pitchFamily="34" charset="-120"/>
+              </a:rPr>
+              <a:t>可安装品牌技能</a:t>
+            </a:r>
+            <a:endParaRPr lang="en-US" sz="1500" dirty="0"/>
+          </a:p>
+        </p:txBody>
+      </p:sp>
+      <p:sp>
+        <p:nvSpPr>
+          <p:cNvPr id="12" name="Shape 9"/>
+          <p:cNvSpPr/>
+          <p:nvPr/>
+        </p:nvSpPr>
+        <p:spPr>
+          <a:xfrm>
+            <a:off x="8173517" y="1828800"/>
+            <a:ext cx="3423818" cy="3200400"/>
+          </a:xfrm>
+          <a:prstGeom prst="roundRect">
+            <a:avLst>
+              <a:gd name="adj" fmla="val 2857"/>
+            </a:avLst>
+          </a:prstGeom>
+          <a:solidFill>
+            <a:srgbClr val="F4F4F5"/>
+          </a:solidFill>
+          <a:ln/>
+        </p:spPr>
+      </p:sp>
+      <p:sp>
+        <p:nvSpPr>
+          <p:cNvPr id="13" name="Text 10"/>
+          <p:cNvSpPr/>
+          <p:nvPr/>
+        </p:nvSpPr>
+        <p:spPr>
+          <a:xfrm>
+            <a:off x="8356397" y="2331720"/>
+            <a:ext cx="3058058" cy="1097280"/>
+          </a:xfrm>
+          <a:prstGeom prst="rect">
+            <a:avLst/>
+          </a:prstGeom>
+          <a:noFill/>
+          <a:ln/>
+        </p:spPr>
+        <p:txBody>
+          <a:bodyPr wrap="square" lIns="0" tIns="0" rIns="0" bIns="0" rtlCol="0" anchor="ctr"/>
+          <a:lstStyle/>
+          <a:p>
+            <a:pPr algn="ctr" indent="0" marL="0">
+              <a:buNone/>
+            </a:pPr>
+            <a:r>
+              <a:rPr lang="en-US" sz="4400" b="1" dirty="0">
+                <a:solidFill>
+                  <a:srgbClr val="AF1F24"/>
+                </a:solidFill>
+                <a:latin typeface="Source Han Sans SC" pitchFamily="34" charset="0"/>
+                <a:ea typeface="Source Han Sans SC" pitchFamily="34" charset="-122"/>
+                <a:cs typeface="Source Han Sans SC" pitchFamily="34" charset="-120"/>
+              </a:rPr>
+              <a:t>16:9</a:t>
+            </a:r>
+            <a:endParaRPr lang="en-US" sz="4400" dirty="0"/>
+          </a:p>
+        </p:txBody>
+      </p:sp>
+      <p:sp>
+        <p:nvSpPr>
+          <p:cNvPr id="14" name="Text 11"/>
+          <p:cNvSpPr/>
+          <p:nvPr/>
+        </p:nvSpPr>
+        <p:spPr>
+          <a:xfrm>
+            <a:off x="8402117" y="3611880"/>
+            <a:ext cx="2966618" cy="822960"/>
+          </a:xfrm>
+          <a:prstGeom prst="rect">
+            <a:avLst/>
+          </a:prstGeom>
+          <a:noFill/>
+          <a:ln/>
+        </p:spPr>
+        <p:txBody>
+          <a:bodyPr wrap="square" lIns="0" tIns="0" rIns="0" bIns="0" rtlCol="0" anchor="ctr"/>
+          <a:lstStyle/>
+          <a:p>
+            <a:pPr algn="ctr" indent="0" marL="0">
+              <a:buNone/>
+            </a:pPr>
+            <a:r>
+              <a:rPr lang="en-US" sz="1500" dirty="0">
+                <a:solidFill>
+                  <a:srgbClr val="171717"/>
+                </a:solidFill>
+                <a:latin typeface="Source Han Sans SC" pitchFamily="34" charset="0"/>
+                <a:ea typeface="Source Han Sans SC" pitchFamily="34" charset="-122"/>
+                <a:cs typeface="Source Han Sans SC" pitchFamily="34" charset="-120"/>
+              </a:rPr>
+              <a:t>统一汇报画幅</a:t>
+            </a:r>
+            <a:endParaRPr lang="en-US" sz="1500" dirty="0"/>
+          </a:p>
+        </p:txBody>
+      </p:sp>
+      <p:sp>
+        <p:nvSpPr>
+          <p:cNvPr id="15" name="Text 12"/>
+          <p:cNvSpPr/>
+          <p:nvPr/>
+        </p:nvSpPr>
+        <p:spPr>
+          <a:xfrm>
+            <a:off x="594360" y="6510528"/>
+            <a:ext cx="6400800" cy="201168"/>
           </a:xfrm>
           <a:prstGeom prst="rect">
             <a:avLst/>
@@ -2504,14 +3720,14 @@
       </p:sp>
       <p:sp>
         <p:nvSpPr>
-          <p:cNvPr id="8" name="Text 5"/>
-          <p:cNvSpPr/>
-          <p:nvPr/>
-        </p:nvSpPr>
-        <p:spPr>
-          <a:xfrm>
-            <a:off x="10515600" y="6492240"/>
-            <a:ext cx="1188720" cy="228600"/>
+          <p:cNvPr id="16" name="Text 13"/>
+          <p:cNvSpPr/>
+          <p:nvPr/>
+        </p:nvSpPr>
+        <p:spPr>
+          <a:xfrm>
+            <a:off x="10500055" y="6510528"/>
+            <a:ext cx="1097280" cy="201168"/>
           </a:xfrm>
           <a:prstGeom prst="rect">
             <a:avLst/>
@@ -2535,9 +3751,215 @@
                 <a:ea typeface="Source Han Sans SC" pitchFamily="34" charset="-122"/>
                 <a:cs typeface="Source Han Sans SC" pitchFamily="34" charset="-120"/>
               </a:rPr>
-              <a:t>5 / 5</a:t>
+              <a:t>6 / 7</a:t>
             </a:r>
             <a:endParaRPr lang="en-US" sz="1000" dirty="0"/>
+          </a:p>
+        </p:txBody>
+      </p:sp>
+    </p:spTree>
+  </p:cSld>
+  <p:clrMapOvr>
+    <a:masterClrMapping/>
+  </p:clrMapOvr>
+</p:sld>
+</file>
+
+<file path=ppt/slides/slide7.xml><?xml version="1.0" encoding="utf-8"?>
+<p:sld xmlns:a="http://schemas.openxmlformats.org/drawingml/2006/main" xmlns:r="http://schemas.openxmlformats.org/officeDocument/2006/relationships" xmlns:p="http://schemas.openxmlformats.org/presentationml/2006/main">
+  <p:cSld name="Slide 7">
+    <p:spTree>
+      <p:nvGrpSpPr>
+        <p:cNvPr id="1" name=""/>
+        <p:cNvGrpSpPr/>
+        <p:nvPr/>
+      </p:nvGrpSpPr>
+      <p:grpSpPr>
+        <a:xfrm>
+          <a:off x="0" y="0"/>
+          <a:ext cx="0" cy="0"/>
+          <a:chOff x="0" y="0"/>
+          <a:chExt cx="0" cy="0"/>
+        </a:xfrm>
+      </p:grpSpPr>
+      <p:sp>
+        <p:nvSpPr>
+          <p:cNvPr id="2" name="Shape 0"/>
+          <p:cNvSpPr/>
+          <p:nvPr/>
+        </p:nvSpPr>
+        <p:spPr>
+          <a:xfrm>
+            <a:off x="0" y="0"/>
+            <a:ext cx="12191695" cy="6858000"/>
+          </a:xfrm>
+          <a:prstGeom prst="rect">
+            <a:avLst/>
+          </a:prstGeom>
+          <a:solidFill>
+            <a:srgbClr val="FFFFFF"/>
+          </a:solidFill>
+          <a:ln/>
+        </p:spPr>
+      </p:sp>
+      <p:pic>
+        <p:nvPicPr>
+          <p:cNvPr id="3" name="Image 0" descr="/workspace/test02-work/repo/skills/sugon-ppt-template/assets/logo.png">    </p:cNvPr>
+          <p:cNvPicPr>
+            <a:picLocks noChangeAspect="1"/>
+          </p:cNvPicPr>
+          <p:nvPr/>
+        </p:nvPicPr>
+        <p:blipFill>
+          <a:blip r:embed="rId1"/>
+          <a:stretch>
+            <a:fillRect/>
+          </a:stretch>
+        </p:blipFill>
+        <p:spPr>
+          <a:xfrm>
+            <a:off x="5227168" y="1965960"/>
+            <a:ext cx="1737360" cy="693280"/>
+          </a:xfrm>
+          <a:prstGeom prst="rect">
+            <a:avLst/>
+          </a:prstGeom>
+        </p:spPr>
+      </p:pic>
+      <p:sp>
+        <p:nvSpPr>
+          <p:cNvPr id="4" name="Text 1"/>
+          <p:cNvSpPr/>
+          <p:nvPr/>
+        </p:nvSpPr>
+        <p:spPr>
+          <a:xfrm>
+            <a:off x="594360" y="3063240"/>
+            <a:ext cx="11002975" cy="640080"/>
+          </a:xfrm>
+          <a:prstGeom prst="rect">
+            <a:avLst/>
+          </a:prstGeom>
+          <a:noFill/>
+          <a:ln/>
+        </p:spPr>
+        <p:txBody>
+          <a:bodyPr wrap="square" lIns="0" tIns="0" rIns="0" bIns="0" rtlCol="0" anchor="ctr"/>
+          <a:lstStyle/>
+          <a:p>
+            <a:pPr algn="ctr" indent="0" marL="0">
+              <a:buNone/>
+            </a:pPr>
+            <a:r>
+              <a:rPr lang="en-US" sz="3600" b="1" dirty="0">
+                <a:solidFill>
+                  <a:srgbClr val="171717"/>
+                </a:solidFill>
+                <a:latin typeface="Source Han Sans SC" pitchFamily="34" charset="0"/>
+                <a:ea typeface="Source Han Sans SC" pitchFamily="34" charset="-122"/>
+                <a:cs typeface="Source Han Sans SC" pitchFamily="34" charset="-120"/>
+              </a:rPr>
+              <a:t>谢谢 · 请指正</a:t>
+            </a:r>
+            <a:endParaRPr lang="en-US" sz="3600" dirty="0"/>
+          </a:p>
+        </p:txBody>
+      </p:sp>
+      <p:sp>
+        <p:nvSpPr>
+          <p:cNvPr id="5" name="Shape 2"/>
+          <p:cNvSpPr/>
+          <p:nvPr/>
+        </p:nvSpPr>
+        <p:spPr>
+          <a:xfrm>
+            <a:off x="5364328" y="3840480"/>
+            <a:ext cx="1463040" cy="36576"/>
+          </a:xfrm>
+          <a:prstGeom prst="rect">
+            <a:avLst/>
+          </a:prstGeom>
+          <a:solidFill>
+            <a:srgbClr val="AF1F24"/>
+          </a:solidFill>
+          <a:ln/>
+        </p:spPr>
+      </p:sp>
+      <p:sp>
+        <p:nvSpPr>
+          <p:cNvPr id="6" name="Text 3"/>
+          <p:cNvSpPr/>
+          <p:nvPr/>
+        </p:nvSpPr>
+        <p:spPr>
+          <a:xfrm>
+            <a:off x="594360" y="4114800"/>
+            <a:ext cx="11002975" cy="365760"/>
+          </a:xfrm>
+          <a:prstGeom prst="rect">
+            <a:avLst/>
+          </a:prstGeom>
+          <a:noFill/>
+          <a:ln/>
+        </p:spPr>
+        <p:txBody>
+          <a:bodyPr wrap="square" lIns="0" tIns="0" rIns="0" bIns="0" rtlCol="0" anchor="ctr"/>
+          <a:lstStyle/>
+          <a:p>
+            <a:pPr algn="ctr" indent="0" marL="0">
+              <a:buNone/>
+            </a:pPr>
+            <a:r>
+              <a:rPr lang="en-US" sz="1600" dirty="0">
+                <a:solidFill>
+                  <a:srgbClr val="525252"/>
+                </a:solidFill>
+                <a:latin typeface="Source Han Sans SC" pitchFamily="34" charset="0"/>
+                <a:ea typeface="Source Han Sans SC" pitchFamily="34" charset="-122"/>
+                <a:cs typeface="Source Han Sans SC" pitchFamily="34" charset="-120"/>
+              </a:rPr>
+              <a:t>曙光云</a:t>
+            </a:r>
+            <a:endParaRPr lang="en-US" sz="1600" dirty="0"/>
+          </a:p>
+        </p:txBody>
+      </p:sp>
+      <p:sp>
+        <p:nvSpPr>
+          <p:cNvPr id="7" name="Text 4"/>
+          <p:cNvSpPr/>
+          <p:nvPr/>
+        </p:nvSpPr>
+        <p:spPr>
+          <a:xfrm>
+            <a:off x="594360" y="4663440"/>
+            <a:ext cx="11002975" cy="320040"/>
+          </a:xfrm>
+          <a:prstGeom prst="rect">
+            <a:avLst/>
+          </a:prstGeom>
+          <a:noFill/>
+          <a:ln/>
+        </p:spPr>
+        <p:txBody>
+          <a:bodyPr wrap="square" lIns="0" tIns="0" rIns="0" bIns="0" rtlCol="0" anchor="ctr"/>
+          <a:lstStyle/>
+          <a:p>
+            <a:pPr algn="ctr" indent="0" marL="0">
+              <a:buNone/>
+            </a:pPr>
+            <a:r>
+              <a:rPr lang="en-US" sz="1300" dirty="0">
+                <a:solidFill>
+                  <a:srgbClr val="525252"/>
+                </a:solidFill>
+                <a:latin typeface="Source Han Sans SC" pitchFamily="34" charset="0"/>
+                <a:ea typeface="Source Han Sans SC" pitchFamily="34" charset="-122"/>
+                <a:cs typeface="Source Han Sans SC" pitchFamily="34" charset="-120"/>
+              </a:rPr>
+              <a:t>联系人 / 邮箱（请替换）</a:t>
+            </a:r>
+            <a:endParaRPr lang="en-US" sz="1300" dirty="0"/>
           </a:p>
         </p:txBody>
       </p:sp>

</xml_diff>